<commit_message>
Complete Project 01 - microservices foundation
</commit_message>
<xml_diff>
--- a/LearningPath/Project-01-Foundation/slides/Project_1_Car_Rental_Microservices_Foundation_Updated_Structure.pptx
+++ b/LearningPath/Project-01-Foundation/slides/Project_1_Car_Rental_Microservices_Foundation_Updated_Structure.pptx
@@ -5,29 +5,29 @@
     <p:sldMasterId id="2147483648" r:id="rId1"/>
   </p:sldMasterIdLst>
   <p:sldIdLst>
-    <p:sldId id="256" r:id="rId7"/>
-    <p:sldId id="257" r:id="rId8"/>
-    <p:sldId id="258" r:id="rId9"/>
-    <p:sldId id="259" r:id="rId10"/>
-    <p:sldId id="260" r:id="rId11"/>
-    <p:sldId id="261" r:id="rId12"/>
-    <p:sldId id="262" r:id="rId13"/>
-    <p:sldId id="263" r:id="rId14"/>
-    <p:sldId id="264" r:id="rId15"/>
-    <p:sldId id="265" r:id="rId16"/>
-    <p:sldId id="266" r:id="rId17"/>
-    <p:sldId id="267" r:id="rId18"/>
-    <p:sldId id="268" r:id="rId19"/>
-    <p:sldId id="269" r:id="rId20"/>
-    <p:sldId id="270" r:id="rId21"/>
-    <p:sldId id="271" r:id="rId22"/>
-    <p:sldId id="272" r:id="rId23"/>
-    <p:sldId id="273" r:id="rId24"/>
-    <p:sldId id="274" r:id="rId25"/>
-    <p:sldId id="275" r:id="rId26"/>
-    <p:sldId id="276" r:id="rId27"/>
+    <p:sldId id="256" r:id="rId2"/>
+    <p:sldId id="257" r:id="rId3"/>
+    <p:sldId id="258" r:id="rId4"/>
+    <p:sldId id="259" r:id="rId5"/>
+    <p:sldId id="260" r:id="rId6"/>
+    <p:sldId id="261" r:id="rId7"/>
+    <p:sldId id="262" r:id="rId8"/>
+    <p:sldId id="263" r:id="rId9"/>
+    <p:sldId id="264" r:id="rId10"/>
+    <p:sldId id="265" r:id="rId11"/>
+    <p:sldId id="266" r:id="rId12"/>
+    <p:sldId id="267" r:id="rId13"/>
+    <p:sldId id="268" r:id="rId14"/>
+    <p:sldId id="269" r:id="rId15"/>
+    <p:sldId id="270" r:id="rId16"/>
+    <p:sldId id="271" r:id="rId17"/>
+    <p:sldId id="272" r:id="rId18"/>
+    <p:sldId id="273" r:id="rId19"/>
+    <p:sldId id="274" r:id="rId20"/>
+    <p:sldId id="275" r:id="rId21"/>
+    <p:sldId id="276" r:id="rId22"/>
   </p:sldIdLst>
-  <p:sldSz cx="12191695" cy="6858000" type="screen4x3"/>
+  <p:sldSz cx="12192000" cy="6858000"/>
   <p:notesSz cx="6858000" cy="9144000"/>
   <p:defaultTextStyle>
     <a:defPPr>
@@ -124,6 +124,22 @@
       </a:defRPr>
     </a:lvl9pPr>
   </p:defaultTextStyle>
+  <p:extLst>
+    <p:ext uri="{EFAFB233-063F-42B5-8137-9DF3F51BA10A}">
+      <p15:sldGuideLst xmlns:p15="http://schemas.microsoft.com/office/powerpoint/2012/main">
+        <p15:guide id="1" orient="horz" pos="2160">
+          <p15:clr>
+            <a:srgbClr val="A4A3A4"/>
+          </p15:clr>
+        </p15:guide>
+        <p15:guide id="2" pos="2880">
+          <p15:clr>
+            <a:srgbClr val="A4A3A4"/>
+          </p15:clr>
+        </p15:guide>
+      </p15:sldGuideLst>
+    </p:ext>
+  </p:extLst>
 </p:presentation>
 </file>
 
@@ -165,10 +181,9 @@
           <a:lstStyle/>
           <a:p>
             <a:r>
-              <a:rPr lang="en-US" smtClean="0"/>
+              <a:rPr lang="en-US"/>
               <a:t>Click to edit Master title style</a:t>
             </a:r>
-            <a:endParaRPr lang="en-US"/>
           </a:p>
         </p:txBody>
       </p:sp>
@@ -284,10 +299,9 @@
           </a:lstStyle>
           <a:p>
             <a:r>
-              <a:rPr lang="en-US" smtClean="0"/>
+              <a:rPr lang="en-US"/>
               <a:t>Click to edit Master subtitle style</a:t>
             </a:r>
-            <a:endParaRPr lang="en-US"/>
           </a:p>
         </p:txBody>
       </p:sp>
@@ -308,7 +322,7 @@
           <a:p>
             <a:fld id="{5BCAD085-E8A6-8845-BD4E-CB4CCA059FC4}" type="datetimeFigureOut">
               <a:rPr lang="en-US" smtClean="0"/>
-              <a:t>1/27/13</a:t>
+              <a:t>10/1/2026</a:t>
             </a:fld>
             <a:endParaRPr lang="en-US"/>
           </a:p>
@@ -402,10 +416,9 @@
           <a:lstStyle/>
           <a:p>
             <a:r>
-              <a:rPr lang="en-US" smtClean="0"/>
+              <a:rPr lang="en-US"/>
               <a:t>Click to edit Master title style</a:t>
             </a:r>
-            <a:endParaRPr lang="en-US"/>
           </a:p>
         </p:txBody>
       </p:sp>
@@ -426,38 +439,37 @@
           <a:p>
             <a:pPr lvl="0"/>
             <a:r>
-              <a:rPr lang="en-US" smtClean="0"/>
+              <a:rPr lang="en-US"/>
               <a:t>Click to edit Master text styles</a:t>
             </a:r>
           </a:p>
           <a:p>
             <a:pPr lvl="1"/>
             <a:r>
-              <a:rPr lang="en-US" smtClean="0"/>
+              <a:rPr lang="en-US"/>
               <a:t>Second level</a:t>
             </a:r>
           </a:p>
           <a:p>
             <a:pPr lvl="2"/>
             <a:r>
-              <a:rPr lang="en-US" smtClean="0"/>
+              <a:rPr lang="en-US"/>
               <a:t>Third level</a:t>
             </a:r>
           </a:p>
           <a:p>
             <a:pPr lvl="3"/>
             <a:r>
-              <a:rPr lang="en-US" smtClean="0"/>
+              <a:rPr lang="en-US"/>
               <a:t>Fourth level</a:t>
             </a:r>
           </a:p>
           <a:p>
             <a:pPr lvl="4"/>
             <a:r>
-              <a:rPr lang="en-US" smtClean="0"/>
+              <a:rPr lang="en-US"/>
               <a:t>Fifth level</a:t>
             </a:r>
-            <a:endParaRPr lang="en-US"/>
           </a:p>
         </p:txBody>
       </p:sp>
@@ -478,7 +490,7 @@
           <a:p>
             <a:fld id="{5BCAD085-E8A6-8845-BD4E-CB4CCA059FC4}" type="datetimeFigureOut">
               <a:rPr lang="en-US" smtClean="0"/>
-              <a:t>1/27/13</a:t>
+              <a:t>10/1/2026</a:t>
             </a:fld>
             <a:endParaRPr lang="en-US"/>
           </a:p>
@@ -577,10 +589,9 @@
           <a:lstStyle/>
           <a:p>
             <a:r>
-              <a:rPr lang="en-US" smtClean="0"/>
+              <a:rPr lang="en-US"/>
               <a:t>Click to edit Master title style</a:t>
             </a:r>
-            <a:endParaRPr lang="en-US"/>
           </a:p>
         </p:txBody>
       </p:sp>
@@ -606,38 +617,37 @@
           <a:p>
             <a:pPr lvl="0"/>
             <a:r>
-              <a:rPr lang="en-US" smtClean="0"/>
+              <a:rPr lang="en-US"/>
               <a:t>Click to edit Master text styles</a:t>
             </a:r>
           </a:p>
           <a:p>
             <a:pPr lvl="1"/>
             <a:r>
-              <a:rPr lang="en-US" smtClean="0"/>
+              <a:rPr lang="en-US"/>
               <a:t>Second level</a:t>
             </a:r>
           </a:p>
           <a:p>
             <a:pPr lvl="2"/>
             <a:r>
-              <a:rPr lang="en-US" smtClean="0"/>
+              <a:rPr lang="en-US"/>
               <a:t>Third level</a:t>
             </a:r>
           </a:p>
           <a:p>
             <a:pPr lvl="3"/>
             <a:r>
-              <a:rPr lang="en-US" smtClean="0"/>
+              <a:rPr lang="en-US"/>
               <a:t>Fourth level</a:t>
             </a:r>
           </a:p>
           <a:p>
             <a:pPr lvl="4"/>
             <a:r>
-              <a:rPr lang="en-US" smtClean="0"/>
+              <a:rPr lang="en-US"/>
               <a:t>Fifth level</a:t>
             </a:r>
-            <a:endParaRPr lang="en-US"/>
           </a:p>
         </p:txBody>
       </p:sp>
@@ -658,7 +668,7 @@
           <a:p>
             <a:fld id="{5BCAD085-E8A6-8845-BD4E-CB4CCA059FC4}" type="datetimeFigureOut">
               <a:rPr lang="en-US" smtClean="0"/>
-              <a:t>1/27/13</a:t>
+              <a:t>10/1/2026</a:t>
             </a:fld>
             <a:endParaRPr lang="en-US"/>
           </a:p>
@@ -752,10 +762,9 @@
           <a:lstStyle/>
           <a:p>
             <a:r>
-              <a:rPr lang="en-US" smtClean="0"/>
+              <a:rPr lang="en-US"/>
               <a:t>Click to edit Master title style</a:t>
             </a:r>
-            <a:endParaRPr lang="en-US"/>
           </a:p>
         </p:txBody>
       </p:sp>
@@ -776,38 +785,37 @@
           <a:p>
             <a:pPr lvl="0"/>
             <a:r>
-              <a:rPr lang="en-US" smtClean="0"/>
+              <a:rPr lang="en-US"/>
               <a:t>Click to edit Master text styles</a:t>
             </a:r>
           </a:p>
           <a:p>
             <a:pPr lvl="1"/>
             <a:r>
-              <a:rPr lang="en-US" smtClean="0"/>
+              <a:rPr lang="en-US"/>
               <a:t>Second level</a:t>
             </a:r>
           </a:p>
           <a:p>
             <a:pPr lvl="2"/>
             <a:r>
-              <a:rPr lang="en-US" smtClean="0"/>
+              <a:rPr lang="en-US"/>
               <a:t>Third level</a:t>
             </a:r>
           </a:p>
           <a:p>
             <a:pPr lvl="3"/>
             <a:r>
-              <a:rPr lang="en-US" smtClean="0"/>
+              <a:rPr lang="en-US"/>
               <a:t>Fourth level</a:t>
             </a:r>
           </a:p>
           <a:p>
             <a:pPr lvl="4"/>
             <a:r>
-              <a:rPr lang="en-US" smtClean="0"/>
+              <a:rPr lang="en-US"/>
               <a:t>Fifth level</a:t>
             </a:r>
-            <a:endParaRPr lang="en-US"/>
           </a:p>
         </p:txBody>
       </p:sp>
@@ -828,7 +836,7 @@
           <a:p>
             <a:fld id="{5BCAD085-E8A6-8845-BD4E-CB4CCA059FC4}" type="datetimeFigureOut">
               <a:rPr lang="en-US" smtClean="0"/>
-              <a:t>1/27/13</a:t>
+              <a:t>10/1/2026</a:t>
             </a:fld>
             <a:endParaRPr lang="en-US"/>
           </a:p>
@@ -931,10 +939,9 @@
           </a:lstStyle>
           <a:p>
             <a:r>
-              <a:rPr lang="en-US" smtClean="0"/>
+              <a:rPr lang="en-US"/>
               <a:t>Click to edit Master title style</a:t>
             </a:r>
-            <a:endParaRPr lang="en-US"/>
           </a:p>
         </p:txBody>
       </p:sp>
@@ -1051,7 +1058,7 @@
           <a:p>
             <a:pPr lvl="0"/>
             <a:r>
-              <a:rPr lang="en-US" smtClean="0"/>
+              <a:rPr lang="en-US"/>
               <a:t>Click to edit Master text styles</a:t>
             </a:r>
           </a:p>
@@ -1074,7 +1081,7 @@
           <a:p>
             <a:fld id="{5BCAD085-E8A6-8845-BD4E-CB4CCA059FC4}" type="datetimeFigureOut">
               <a:rPr lang="en-US" smtClean="0"/>
-              <a:t>1/27/13</a:t>
+              <a:t>10/1/2026</a:t>
             </a:fld>
             <a:endParaRPr lang="en-US"/>
           </a:p>
@@ -1168,10 +1175,9 @@
           <a:lstStyle/>
           <a:p>
             <a:r>
-              <a:rPr lang="en-US" smtClean="0"/>
+              <a:rPr lang="en-US"/>
               <a:t>Click to edit Master title style</a:t>
             </a:r>
-            <a:endParaRPr lang="en-US"/>
           </a:p>
         </p:txBody>
       </p:sp>
@@ -1225,38 +1231,37 @@
           <a:p>
             <a:pPr lvl="0"/>
             <a:r>
-              <a:rPr lang="en-US" smtClean="0"/>
+              <a:rPr lang="en-US"/>
               <a:t>Click to edit Master text styles</a:t>
             </a:r>
           </a:p>
           <a:p>
             <a:pPr lvl="1"/>
             <a:r>
-              <a:rPr lang="en-US" smtClean="0"/>
+              <a:rPr lang="en-US"/>
               <a:t>Second level</a:t>
             </a:r>
           </a:p>
           <a:p>
             <a:pPr lvl="2"/>
             <a:r>
-              <a:rPr lang="en-US" smtClean="0"/>
+              <a:rPr lang="en-US"/>
               <a:t>Third level</a:t>
             </a:r>
           </a:p>
           <a:p>
             <a:pPr lvl="3"/>
             <a:r>
-              <a:rPr lang="en-US" smtClean="0"/>
+              <a:rPr lang="en-US"/>
               <a:t>Fourth level</a:t>
             </a:r>
           </a:p>
           <a:p>
             <a:pPr lvl="4"/>
             <a:r>
-              <a:rPr lang="en-US" smtClean="0"/>
+              <a:rPr lang="en-US"/>
               <a:t>Fifth level</a:t>
             </a:r>
-            <a:endParaRPr lang="en-US"/>
           </a:p>
         </p:txBody>
       </p:sp>
@@ -1310,38 +1315,37 @@
           <a:p>
             <a:pPr lvl="0"/>
             <a:r>
-              <a:rPr lang="en-US" smtClean="0"/>
+              <a:rPr lang="en-US"/>
               <a:t>Click to edit Master text styles</a:t>
             </a:r>
           </a:p>
           <a:p>
             <a:pPr lvl="1"/>
             <a:r>
-              <a:rPr lang="en-US" smtClean="0"/>
+              <a:rPr lang="en-US"/>
               <a:t>Second level</a:t>
             </a:r>
           </a:p>
           <a:p>
             <a:pPr lvl="2"/>
             <a:r>
-              <a:rPr lang="en-US" smtClean="0"/>
+              <a:rPr lang="en-US"/>
               <a:t>Third level</a:t>
             </a:r>
           </a:p>
           <a:p>
             <a:pPr lvl="3"/>
             <a:r>
-              <a:rPr lang="en-US" smtClean="0"/>
+              <a:rPr lang="en-US"/>
               <a:t>Fourth level</a:t>
             </a:r>
           </a:p>
           <a:p>
             <a:pPr lvl="4"/>
             <a:r>
-              <a:rPr lang="en-US" smtClean="0"/>
+              <a:rPr lang="en-US"/>
               <a:t>Fifth level</a:t>
             </a:r>
-            <a:endParaRPr lang="en-US"/>
           </a:p>
         </p:txBody>
       </p:sp>
@@ -1362,7 +1366,7 @@
           <a:p>
             <a:fld id="{5BCAD085-E8A6-8845-BD4E-CB4CCA059FC4}" type="datetimeFigureOut">
               <a:rPr lang="en-US" smtClean="0"/>
-              <a:t>1/27/13</a:t>
+              <a:t>10/1/2026</a:t>
             </a:fld>
             <a:endParaRPr lang="en-US"/>
           </a:p>
@@ -1460,10 +1464,9 @@
           </a:lstStyle>
           <a:p>
             <a:r>
-              <a:rPr lang="en-US" smtClean="0"/>
+              <a:rPr lang="en-US"/>
               <a:t>Click to edit Master title style</a:t>
             </a:r>
-            <a:endParaRPr lang="en-US"/>
           </a:p>
         </p:txBody>
       </p:sp>
@@ -1526,7 +1529,7 @@
           <a:p>
             <a:pPr lvl="0"/>
             <a:r>
-              <a:rPr lang="en-US" smtClean="0"/>
+              <a:rPr lang="en-US"/>
               <a:t>Click to edit Master text styles</a:t>
             </a:r>
           </a:p>
@@ -1582,38 +1585,37 @@
           <a:p>
             <a:pPr lvl="0"/>
             <a:r>
-              <a:rPr lang="en-US" smtClean="0"/>
+              <a:rPr lang="en-US"/>
               <a:t>Click to edit Master text styles</a:t>
             </a:r>
           </a:p>
           <a:p>
             <a:pPr lvl="1"/>
             <a:r>
-              <a:rPr lang="en-US" smtClean="0"/>
+              <a:rPr lang="en-US"/>
               <a:t>Second level</a:t>
             </a:r>
           </a:p>
           <a:p>
             <a:pPr lvl="2"/>
             <a:r>
-              <a:rPr lang="en-US" smtClean="0"/>
+              <a:rPr lang="en-US"/>
               <a:t>Third level</a:t>
             </a:r>
           </a:p>
           <a:p>
             <a:pPr lvl="3"/>
             <a:r>
-              <a:rPr lang="en-US" smtClean="0"/>
+              <a:rPr lang="en-US"/>
               <a:t>Fourth level</a:t>
             </a:r>
           </a:p>
           <a:p>
             <a:pPr lvl="4"/>
             <a:r>
-              <a:rPr lang="en-US" smtClean="0"/>
+              <a:rPr lang="en-US"/>
               <a:t>Fifth level</a:t>
             </a:r>
-            <a:endParaRPr lang="en-US"/>
           </a:p>
         </p:txBody>
       </p:sp>
@@ -1676,7 +1678,7 @@
           <a:p>
             <a:pPr lvl="0"/>
             <a:r>
-              <a:rPr lang="en-US" smtClean="0"/>
+              <a:rPr lang="en-US"/>
               <a:t>Click to edit Master text styles</a:t>
             </a:r>
           </a:p>
@@ -1732,38 +1734,37 @@
           <a:p>
             <a:pPr lvl="0"/>
             <a:r>
-              <a:rPr lang="en-US" smtClean="0"/>
+              <a:rPr lang="en-US"/>
               <a:t>Click to edit Master text styles</a:t>
             </a:r>
           </a:p>
           <a:p>
             <a:pPr lvl="1"/>
             <a:r>
-              <a:rPr lang="en-US" smtClean="0"/>
+              <a:rPr lang="en-US"/>
               <a:t>Second level</a:t>
             </a:r>
           </a:p>
           <a:p>
             <a:pPr lvl="2"/>
             <a:r>
-              <a:rPr lang="en-US" smtClean="0"/>
+              <a:rPr lang="en-US"/>
               <a:t>Third level</a:t>
             </a:r>
           </a:p>
           <a:p>
             <a:pPr lvl="3"/>
             <a:r>
-              <a:rPr lang="en-US" smtClean="0"/>
+              <a:rPr lang="en-US"/>
               <a:t>Fourth level</a:t>
             </a:r>
           </a:p>
           <a:p>
             <a:pPr lvl="4"/>
             <a:r>
-              <a:rPr lang="en-US" smtClean="0"/>
+              <a:rPr lang="en-US"/>
               <a:t>Fifth level</a:t>
             </a:r>
-            <a:endParaRPr lang="en-US"/>
           </a:p>
         </p:txBody>
       </p:sp>
@@ -1784,7 +1785,7 @@
           <a:p>
             <a:fld id="{5BCAD085-E8A6-8845-BD4E-CB4CCA059FC4}" type="datetimeFigureOut">
               <a:rPr lang="en-US" smtClean="0"/>
-              <a:t>1/27/13</a:t>
+              <a:t>10/1/2026</a:t>
             </a:fld>
             <a:endParaRPr lang="en-US"/>
           </a:p>
@@ -1878,10 +1879,9 @@
           <a:lstStyle/>
           <a:p>
             <a:r>
-              <a:rPr lang="en-US" smtClean="0"/>
+              <a:rPr lang="en-US"/>
               <a:t>Click to edit Master title style</a:t>
             </a:r>
-            <a:endParaRPr lang="en-US"/>
           </a:p>
         </p:txBody>
       </p:sp>
@@ -1902,7 +1902,7 @@
           <a:p>
             <a:fld id="{5BCAD085-E8A6-8845-BD4E-CB4CCA059FC4}" type="datetimeFigureOut">
               <a:rPr lang="en-US" smtClean="0"/>
-              <a:t>1/27/13</a:t>
+              <a:t>10/1/2026</a:t>
             </a:fld>
             <a:endParaRPr lang="en-US"/>
           </a:p>
@@ -1997,7 +1997,7 @@
           <a:p>
             <a:fld id="{5BCAD085-E8A6-8845-BD4E-CB4CCA059FC4}" type="datetimeFigureOut">
               <a:rPr lang="en-US" smtClean="0"/>
-              <a:t>1/27/13</a:t>
+              <a:t>10/1/2026</a:t>
             </a:fld>
             <a:endParaRPr lang="en-US"/>
           </a:p>
@@ -2100,10 +2100,9 @@
           </a:lstStyle>
           <a:p>
             <a:r>
-              <a:rPr lang="en-US" smtClean="0"/>
+              <a:rPr lang="en-US"/>
               <a:t>Click to edit Master title style</a:t>
             </a:r>
-            <a:endParaRPr lang="en-US"/>
           </a:p>
         </p:txBody>
       </p:sp>
@@ -2157,38 +2156,37 @@
           <a:p>
             <a:pPr lvl="0"/>
             <a:r>
-              <a:rPr lang="en-US" smtClean="0"/>
+              <a:rPr lang="en-US"/>
               <a:t>Click to edit Master text styles</a:t>
             </a:r>
           </a:p>
           <a:p>
             <a:pPr lvl="1"/>
             <a:r>
-              <a:rPr lang="en-US" smtClean="0"/>
+              <a:rPr lang="en-US"/>
               <a:t>Second level</a:t>
             </a:r>
           </a:p>
           <a:p>
             <a:pPr lvl="2"/>
             <a:r>
-              <a:rPr lang="en-US" smtClean="0"/>
+              <a:rPr lang="en-US"/>
               <a:t>Third level</a:t>
             </a:r>
           </a:p>
           <a:p>
             <a:pPr lvl="3"/>
             <a:r>
-              <a:rPr lang="en-US" smtClean="0"/>
+              <a:rPr lang="en-US"/>
               <a:t>Fourth level</a:t>
             </a:r>
           </a:p>
           <a:p>
             <a:pPr lvl="4"/>
             <a:r>
-              <a:rPr lang="en-US" smtClean="0"/>
+              <a:rPr lang="en-US"/>
               <a:t>Fifth level</a:t>
             </a:r>
-            <a:endParaRPr lang="en-US"/>
           </a:p>
         </p:txBody>
       </p:sp>
@@ -2251,7 +2249,7 @@
           <a:p>
             <a:pPr lvl="0"/>
             <a:r>
-              <a:rPr lang="en-US" smtClean="0"/>
+              <a:rPr lang="en-US"/>
               <a:t>Click to edit Master text styles</a:t>
             </a:r>
           </a:p>
@@ -2274,7 +2272,7 @@
           <a:p>
             <a:fld id="{5BCAD085-E8A6-8845-BD4E-CB4CCA059FC4}" type="datetimeFigureOut">
               <a:rPr lang="en-US" smtClean="0"/>
-              <a:t>1/27/13</a:t>
+              <a:t>10/1/2026</a:t>
             </a:fld>
             <a:endParaRPr lang="en-US"/>
           </a:p>
@@ -2377,10 +2375,9 @@
           </a:lstStyle>
           <a:p>
             <a:r>
-              <a:rPr lang="en-US" smtClean="0"/>
+              <a:rPr lang="en-US"/>
               <a:t>Click to edit Master title style</a:t>
             </a:r>
-            <a:endParaRPr lang="en-US"/>
           </a:p>
         </p:txBody>
       </p:sp>
@@ -2504,7 +2501,7 @@
           <a:p>
             <a:pPr lvl="0"/>
             <a:r>
-              <a:rPr lang="en-US" smtClean="0"/>
+              <a:rPr lang="en-US"/>
               <a:t>Click to edit Master text styles</a:t>
             </a:r>
           </a:p>
@@ -2527,7 +2524,7 @@
           <a:p>
             <a:fld id="{5BCAD085-E8A6-8845-BD4E-CB4CCA059FC4}" type="datetimeFigureOut">
               <a:rPr lang="en-US" smtClean="0"/>
-              <a:t>1/27/13</a:t>
+              <a:t>10/1/2026</a:t>
             </a:fld>
             <a:endParaRPr lang="en-US"/>
           </a:p>
@@ -2636,10 +2633,9 @@
           <a:lstStyle/>
           <a:p>
             <a:r>
-              <a:rPr lang="en-US" smtClean="0"/>
+              <a:rPr lang="en-US"/>
               <a:t>Click to edit Master title style</a:t>
             </a:r>
-            <a:endParaRPr lang="en-US"/>
           </a:p>
         </p:txBody>
       </p:sp>
@@ -2670,38 +2666,37 @@
           <a:p>
             <a:pPr lvl="0"/>
             <a:r>
-              <a:rPr lang="en-US" smtClean="0"/>
+              <a:rPr lang="en-US"/>
               <a:t>Click to edit Master text styles</a:t>
             </a:r>
           </a:p>
           <a:p>
             <a:pPr lvl="1"/>
             <a:r>
-              <a:rPr lang="en-US" smtClean="0"/>
+              <a:rPr lang="en-US"/>
               <a:t>Second level</a:t>
             </a:r>
           </a:p>
           <a:p>
             <a:pPr lvl="2"/>
             <a:r>
-              <a:rPr lang="en-US" smtClean="0"/>
+              <a:rPr lang="en-US"/>
               <a:t>Third level</a:t>
             </a:r>
           </a:p>
           <a:p>
             <a:pPr lvl="3"/>
             <a:r>
-              <a:rPr lang="en-US" smtClean="0"/>
+              <a:rPr lang="en-US"/>
               <a:t>Fourth level</a:t>
             </a:r>
           </a:p>
           <a:p>
             <a:pPr lvl="4"/>
             <a:r>
-              <a:rPr lang="en-US" smtClean="0"/>
+              <a:rPr lang="en-US"/>
               <a:t>Fifth level</a:t>
             </a:r>
-            <a:endParaRPr lang="en-US"/>
           </a:p>
         </p:txBody>
       </p:sp>
@@ -2740,7 +2735,7 @@
           <a:p>
             <a:fld id="{5BCAD085-E8A6-8845-BD4E-CB4CCA059FC4}" type="datetimeFigureOut">
               <a:rPr lang="en-US" smtClean="0"/>
-              <a:t>1/27/13</a:t>
+              <a:t>10/1/2026</a:t>
             </a:fld>
             <a:endParaRPr lang="en-US"/>
           </a:p>
@@ -3099,7 +3094,7 @@
 </file>
 
 <file path=ppt/slides/slide1.xml><?xml version="1.0" encoding="utf-8"?>
-<p:sld xmlns:a="http://schemas.openxmlformats.org/drawingml/2006/main" xmlns:p="http://schemas.openxmlformats.org/presentationml/2006/main" xmlns:r="http://schemas.openxmlformats.org/officeDocument/2006/relationships">
+<p:sld xmlns:a="http://schemas.openxmlformats.org/drawingml/2006/main" xmlns:r="http://schemas.openxmlformats.org/officeDocument/2006/relationships" xmlns:p="http://schemas.openxmlformats.org/presentationml/2006/main">
   <p:cSld>
     <p:bg>
       <p:bgPr>
@@ -3115,7 +3110,14 @@
         <p:cNvGrpSpPr/>
         <p:nvPr/>
       </p:nvGrpSpPr>
-      <p:grpSpPr/>
+      <p:grpSpPr>
+        <a:xfrm>
+          <a:off x="0" y="0"/>
+          <a:ext cx="0" cy="0"/>
+          <a:chOff x="0" y="0"/>
+          <a:chExt cx="0" cy="0"/>
+        </a:xfrm>
+      </p:grpSpPr>
       <p:sp>
         <p:nvSpPr>
           <p:cNvPr id="2" name="TextBox 1"/>
@@ -3219,7 +3221,7 @@
 </file>
 
 <file path=ppt/slides/slide10.xml><?xml version="1.0" encoding="utf-8"?>
-<p:sld xmlns:a="http://schemas.openxmlformats.org/drawingml/2006/main" xmlns:p="http://schemas.openxmlformats.org/presentationml/2006/main" xmlns:r="http://schemas.openxmlformats.org/officeDocument/2006/relationships">
+<p:sld xmlns:a="http://schemas.openxmlformats.org/drawingml/2006/main" xmlns:r="http://schemas.openxmlformats.org/officeDocument/2006/relationships" xmlns:p="http://schemas.openxmlformats.org/presentationml/2006/main">
   <p:cSld>
     <p:bg>
       <p:bgPr>
@@ -3235,7 +3237,14 @@
         <p:cNvGrpSpPr/>
         <p:nvPr/>
       </p:nvGrpSpPr>
-      <p:grpSpPr/>
+      <p:grpSpPr>
+        <a:xfrm>
+          <a:off x="0" y="0"/>
+          <a:ext cx="0" cy="0"/>
+          <a:chOff x="0" y="0"/>
+          <a:chExt cx="0" cy="0"/>
+        </a:xfrm>
+      </p:grpSpPr>
       <p:sp>
         <p:nvSpPr>
           <p:cNvPr id="2" name="TextBox 1"/>
@@ -3311,6 +3320,7 @@
           <a:lstStyle/>
           <a:p>
             <a:pPr algn="ctr"/>
+            <a:endParaRPr/>
           </a:p>
         </p:txBody>
       </p:sp>
@@ -3387,131 +3397,411 @@
           </a:fontRef>
         </p:style>
         <p:txBody>
-          <a:bodyPr rtlCol="0" anchor="ctr" wrap="square"/>
-          <a:lstStyle/>
-          <a:p>
-            <a:r>
+          <a:bodyPr wrap="square" rtlCol="0" anchor="ctr"/>
+          <a:lstStyle/>
+          <a:p>
+            <a:r>
+              <a:rPr dirty="0">
+                <a:highlight>
+                  <a:srgbClr val="000080"/>
+                </a:highlight>
+              </a:rPr>
               <a:t># Python</a:t>
             </a:r>
           </a:p>
           <a:p>
             <a:r>
-              <a:t>__pycache__/</a:t>
-            </a:r>
-          </a:p>
-          <a:p>
-            <a:r>
-              <a:t>*.py[cod]</a:t>
-            </a:r>
-          </a:p>
-          <a:p/>
-          <a:p>
-            <a:r>
+              <a:rPr dirty="0">
+                <a:highlight>
+                  <a:srgbClr val="000080"/>
+                </a:highlight>
+              </a:rPr>
+              <a:t>__</a:t>
+            </a:r>
+            <a:r>
+              <a:rPr dirty="0" err="1">
+                <a:highlight>
+                  <a:srgbClr val="000080"/>
+                </a:highlight>
+              </a:rPr>
+              <a:t>pycache</a:t>
+            </a:r>
+            <a:r>
+              <a:rPr dirty="0">
+                <a:highlight>
+                  <a:srgbClr val="000080"/>
+                </a:highlight>
+              </a:rPr>
+              <a:t>__/</a:t>
+            </a:r>
+          </a:p>
+          <a:p>
+            <a:r>
+              <a:rPr dirty="0">
+                <a:highlight>
+                  <a:srgbClr val="000080"/>
+                </a:highlight>
+              </a:rPr>
+              <a:t>*.</a:t>
+            </a:r>
+            <a:r>
+              <a:rPr dirty="0" err="1">
+                <a:highlight>
+                  <a:srgbClr val="000080"/>
+                </a:highlight>
+              </a:rPr>
+              <a:t>py</a:t>
+            </a:r>
+            <a:r>
+              <a:rPr dirty="0">
+                <a:highlight>
+                  <a:srgbClr val="000080"/>
+                </a:highlight>
+              </a:rPr>
+              <a:t>[cod]</a:t>
+            </a:r>
+          </a:p>
+          <a:p>
+            <a:endParaRPr dirty="0">
+              <a:highlight>
+                <a:srgbClr val="000080"/>
+              </a:highlight>
+            </a:endParaRPr>
+          </a:p>
+          <a:p>
+            <a:r>
+              <a:rPr dirty="0">
+                <a:highlight>
+                  <a:srgbClr val="000080"/>
+                </a:highlight>
+              </a:rPr>
               <a:t># Virtual environments</a:t>
             </a:r>
           </a:p>
           <a:p>
             <a:r>
-              <a:t>.venv/</a:t>
-            </a:r>
-          </a:p>
-          <a:p>
-            <a:r>
-              <a:t>venv/</a:t>
-            </a:r>
-          </a:p>
-          <a:p>
-            <a:r>
+              <a:rPr dirty="0">
+                <a:highlight>
+                  <a:srgbClr val="000080"/>
+                </a:highlight>
+              </a:rPr>
+              <a:t>.</a:t>
+            </a:r>
+            <a:r>
+              <a:rPr dirty="0" err="1">
+                <a:highlight>
+                  <a:srgbClr val="000080"/>
+                </a:highlight>
+              </a:rPr>
+              <a:t>venv</a:t>
+            </a:r>
+            <a:r>
+              <a:rPr dirty="0">
+                <a:highlight>
+                  <a:srgbClr val="000080"/>
+                </a:highlight>
+              </a:rPr>
+              <a:t>/</a:t>
+            </a:r>
+          </a:p>
+          <a:p>
+            <a:r>
+              <a:rPr dirty="0" err="1">
+                <a:highlight>
+                  <a:srgbClr val="000080"/>
+                </a:highlight>
+              </a:rPr>
+              <a:t>venv</a:t>
+            </a:r>
+            <a:r>
+              <a:rPr dirty="0">
+                <a:highlight>
+                  <a:srgbClr val="000080"/>
+                </a:highlight>
+              </a:rPr>
+              <a:t>/</a:t>
+            </a:r>
+          </a:p>
+          <a:p>
+            <a:r>
+              <a:rPr dirty="0">
+                <a:highlight>
+                  <a:srgbClr val="000080"/>
+                </a:highlight>
+              </a:rPr>
               <a:t>env/</a:t>
             </a:r>
           </a:p>
-          <a:p/>
-          <a:p>
-            <a:r>
+          <a:p>
+            <a:endParaRPr dirty="0">
+              <a:highlight>
+                <a:srgbClr val="000080"/>
+              </a:highlight>
+            </a:endParaRPr>
+          </a:p>
+          <a:p>
+            <a:r>
+              <a:rPr dirty="0">
+                <a:highlight>
+                  <a:srgbClr val="000080"/>
+                </a:highlight>
+              </a:rPr>
               <a:t># Secrets / environment variables</a:t>
             </a:r>
           </a:p>
           <a:p>
             <a:r>
+              <a:rPr dirty="0">
+                <a:highlight>
+                  <a:srgbClr val="000080"/>
+                </a:highlight>
+              </a:rPr>
               <a:t>.env</a:t>
             </a:r>
           </a:p>
           <a:p>
             <a:r>
+              <a:rPr dirty="0">
+                <a:highlight>
+                  <a:srgbClr val="000080"/>
+                </a:highlight>
+              </a:rPr>
               <a:t>.env.*</a:t>
             </a:r>
           </a:p>
-          <a:p/>
-          <a:p>
-            <a:r>
+          <a:p>
+            <a:endParaRPr dirty="0">
+              <a:highlight>
+                <a:srgbClr val="000080"/>
+              </a:highlight>
+            </a:endParaRPr>
+          </a:p>
+          <a:p>
+            <a:r>
+              <a:rPr dirty="0">
+                <a:highlight>
+                  <a:srgbClr val="000080"/>
+                </a:highlight>
+              </a:rPr>
               <a:t># Microsoft Office temporary lock files</a:t>
             </a:r>
           </a:p>
           <a:p>
             <a:r>
+              <a:rPr dirty="0">
+                <a:highlight>
+                  <a:srgbClr val="000080"/>
+                </a:highlight>
+              </a:rPr>
               <a:t>~$*</a:t>
             </a:r>
           </a:p>
-          <a:p/>
-          <a:p>
-            <a:r>
+          <a:p>
+            <a:endParaRPr dirty="0">
+              <a:highlight>
+                <a:srgbClr val="000080"/>
+              </a:highlight>
+            </a:endParaRPr>
+          </a:p>
+          <a:p>
+            <a:r>
+              <a:rPr dirty="0">
+                <a:highlight>
+                  <a:srgbClr val="000080"/>
+                </a:highlight>
+              </a:rPr>
               <a:t># Terraform</a:t>
             </a:r>
           </a:p>
           <a:p>
             <a:r>
+              <a:rPr dirty="0">
+                <a:highlight>
+                  <a:srgbClr val="000080"/>
+                </a:highlight>
+              </a:rPr>
               <a:t>.terraform/</a:t>
             </a:r>
           </a:p>
           <a:p>
             <a:r>
-              <a:t>*.tfstate</a:t>
-            </a:r>
-          </a:p>
-          <a:p>
-            <a:r>
-              <a:t>*.tfstate.*</a:t>
-            </a:r>
-          </a:p>
-          <a:p>
-            <a:r>
-              <a:t>*.tfvars</a:t>
-            </a:r>
-          </a:p>
-          <a:p/>
-          <a:p>
-            <a:r>
+              <a:rPr dirty="0">
+                <a:highlight>
+                  <a:srgbClr val="000080"/>
+                </a:highlight>
+              </a:rPr>
+              <a:t>*.</a:t>
+            </a:r>
+            <a:r>
+              <a:rPr dirty="0" err="1">
+                <a:highlight>
+                  <a:srgbClr val="000080"/>
+                </a:highlight>
+              </a:rPr>
+              <a:t>tfstate</a:t>
+            </a:r>
+            <a:endParaRPr dirty="0">
+              <a:highlight>
+                <a:srgbClr val="000080"/>
+              </a:highlight>
+            </a:endParaRPr>
+          </a:p>
+          <a:p>
+            <a:r>
+              <a:rPr dirty="0">
+                <a:highlight>
+                  <a:srgbClr val="000080"/>
+                </a:highlight>
+              </a:rPr>
+              <a:t>*.</a:t>
+            </a:r>
+            <a:r>
+              <a:rPr dirty="0" err="1">
+                <a:highlight>
+                  <a:srgbClr val="000080"/>
+                </a:highlight>
+              </a:rPr>
+              <a:t>tfstate</a:t>
+            </a:r>
+            <a:r>
+              <a:rPr dirty="0">
+                <a:highlight>
+                  <a:srgbClr val="000080"/>
+                </a:highlight>
+              </a:rPr>
+              <a:t>.*</a:t>
+            </a:r>
+          </a:p>
+          <a:p>
+            <a:r>
+              <a:rPr dirty="0">
+                <a:highlight>
+                  <a:srgbClr val="000080"/>
+                </a:highlight>
+              </a:rPr>
+              <a:t>*.</a:t>
+            </a:r>
+            <a:r>
+              <a:rPr dirty="0" err="1">
+                <a:highlight>
+                  <a:srgbClr val="000080"/>
+                </a:highlight>
+              </a:rPr>
+              <a:t>tfvars</a:t>
+            </a:r>
+            <a:endParaRPr dirty="0">
+              <a:highlight>
+                <a:srgbClr val="000080"/>
+              </a:highlight>
+            </a:endParaRPr>
+          </a:p>
+          <a:p>
+            <a:endParaRPr dirty="0">
+              <a:highlight>
+                <a:srgbClr val="000080"/>
+              </a:highlight>
+            </a:endParaRPr>
+          </a:p>
+          <a:p>
+            <a:r>
+              <a:rPr dirty="0">
+                <a:highlight>
+                  <a:srgbClr val="000080"/>
+                </a:highlight>
+              </a:rPr>
               <a:t># Node / Next.js</a:t>
             </a:r>
           </a:p>
           <a:p>
             <a:r>
-              <a:t>node_modules/</a:t>
-            </a:r>
-          </a:p>
-          <a:p>
-            <a:r>
+              <a:rPr dirty="0" err="1">
+                <a:highlight>
+                  <a:srgbClr val="000080"/>
+                </a:highlight>
+              </a:rPr>
+              <a:t>node_modules</a:t>
+            </a:r>
+            <a:r>
+              <a:rPr dirty="0">
+                <a:highlight>
+                  <a:srgbClr val="000080"/>
+                </a:highlight>
+              </a:rPr>
+              <a:t>/</a:t>
+            </a:r>
+          </a:p>
+          <a:p>
+            <a:r>
+              <a:rPr dirty="0">
+                <a:highlight>
+                  <a:srgbClr val="000080"/>
+                </a:highlight>
+              </a:rPr>
               <a:t>.next/</a:t>
             </a:r>
           </a:p>
-          <a:p/>
-          <a:p>
-            <a:r>
+          <a:p>
+            <a:endParaRPr dirty="0">
+              <a:highlight>
+                <a:srgbClr val="000080"/>
+              </a:highlight>
+            </a:endParaRPr>
+          </a:p>
+          <a:p>
+            <a:r>
+              <a:rPr dirty="0">
+                <a:highlight>
+                  <a:srgbClr val="000080"/>
+                </a:highlight>
+              </a:rPr>
               <a:t># OS / logs</a:t>
             </a:r>
           </a:p>
           <a:p>
             <a:r>
+              <a:rPr dirty="0" err="1">
+                <a:highlight>
+                  <a:srgbClr val="000080"/>
+                </a:highlight>
+              </a:rPr>
               <a:t>Thumbs.db</a:t>
             </a:r>
-          </a:p>
-          <a:p>
-            <a:r>
-              <a:t>.DS_Store</a:t>
-            </a:r>
-          </a:p>
-          <a:p>
-            <a:r>
+            <a:endParaRPr dirty="0">
+              <a:highlight>
+                <a:srgbClr val="000080"/>
+              </a:highlight>
+            </a:endParaRPr>
+          </a:p>
+          <a:p>
+            <a:r>
+              <a:rPr dirty="0">
+                <a:highlight>
+                  <a:srgbClr val="000080"/>
+                </a:highlight>
+              </a:rPr>
+              <a:t>.</a:t>
+            </a:r>
+            <a:r>
+              <a:rPr dirty="0" err="1">
+                <a:highlight>
+                  <a:srgbClr val="000080"/>
+                </a:highlight>
+              </a:rPr>
+              <a:t>DS_Store</a:t>
+            </a:r>
+            <a:endParaRPr dirty="0">
+              <a:highlight>
+                <a:srgbClr val="000080"/>
+              </a:highlight>
+            </a:endParaRPr>
+          </a:p>
+          <a:p>
+            <a:r>
+              <a:rPr dirty="0">
+                <a:highlight>
+                  <a:srgbClr val="000080"/>
+                </a:highlight>
+              </a:rPr>
               <a:t>*.log</a:t>
             </a:r>
           </a:p>
@@ -3526,7 +3816,7 @@
 </file>
 
 <file path=ppt/slides/slide11.xml><?xml version="1.0" encoding="utf-8"?>
-<p:sld xmlns:a="http://schemas.openxmlformats.org/drawingml/2006/main" xmlns:p="http://schemas.openxmlformats.org/presentationml/2006/main" xmlns:r="http://schemas.openxmlformats.org/officeDocument/2006/relationships">
+<p:sld xmlns:a="http://schemas.openxmlformats.org/drawingml/2006/main" xmlns:r="http://schemas.openxmlformats.org/officeDocument/2006/relationships" xmlns:p="http://schemas.openxmlformats.org/presentationml/2006/main">
   <p:cSld>
     <p:bg>
       <p:bgPr>
@@ -3542,7 +3832,14 @@
         <p:cNvGrpSpPr/>
         <p:nvPr/>
       </p:nvGrpSpPr>
-      <p:grpSpPr/>
+      <p:grpSpPr>
+        <a:xfrm>
+          <a:off x="0" y="0"/>
+          <a:ext cx="0" cy="0"/>
+          <a:chOff x="0" y="0"/>
+          <a:chExt cx="0" cy="0"/>
+        </a:xfrm>
+      </p:grpSpPr>
       <p:sp>
         <p:nvSpPr>
           <p:cNvPr id="2" name="TextBox 1"/>
@@ -3618,6 +3915,7 @@
           <a:lstStyle/>
           <a:p>
             <a:pPr algn="ctr"/>
+            <a:endParaRPr/>
           </a:p>
         </p:txBody>
       </p:sp>
@@ -3718,7 +4016,7 @@
 </file>
 
 <file path=ppt/slides/slide12.xml><?xml version="1.0" encoding="utf-8"?>
-<p:sld xmlns:a="http://schemas.openxmlformats.org/drawingml/2006/main" xmlns:p="http://schemas.openxmlformats.org/presentationml/2006/main" xmlns:r="http://schemas.openxmlformats.org/officeDocument/2006/relationships">
+<p:sld xmlns:a="http://schemas.openxmlformats.org/drawingml/2006/main" xmlns:r="http://schemas.openxmlformats.org/officeDocument/2006/relationships" xmlns:p="http://schemas.openxmlformats.org/presentationml/2006/main">
   <p:cSld>
     <p:bg>
       <p:bgPr>
@@ -3734,7 +4032,14 @@
         <p:cNvGrpSpPr/>
         <p:nvPr/>
       </p:nvGrpSpPr>
-      <p:grpSpPr/>
+      <p:grpSpPr>
+        <a:xfrm>
+          <a:off x="0" y="0"/>
+          <a:ext cx="0" cy="0"/>
+          <a:chOff x="0" y="0"/>
+          <a:chExt cx="0" cy="0"/>
+        </a:xfrm>
+      </p:grpSpPr>
       <p:sp>
         <p:nvSpPr>
           <p:cNvPr id="2" name="TextBox 1"/>
@@ -3810,6 +4115,7 @@
           <a:lstStyle/>
           <a:p>
             <a:pPr algn="ctr"/>
+            <a:endParaRPr/>
           </a:p>
         </p:txBody>
       </p:sp>
@@ -3886,7 +4192,7 @@
           </a:fontRef>
         </p:style>
         <p:txBody>
-          <a:bodyPr rtlCol="0" anchor="ctr" wrap="square"/>
+          <a:bodyPr wrap="square" rtlCol="0" anchor="ctr"/>
           <a:lstStyle/>
           <a:p>
             <a:r>
@@ -3913,7 +4219,9 @@
               <a:t>        └── requirements.txt</a:t>
             </a:r>
           </a:p>
-          <a:p/>
+          <a:p>
+            <a:endParaRPr/>
+          </a:p>
           <a:p>
             <a:r>
               <a:t># Purpose:</a:t>
@@ -3934,7 +4242,9 @@
               <a:t># Later, each real microservice exposes its own health endpoint.</a:t>
             </a:r>
           </a:p>
-          <a:p/>
+          <a:p>
+            <a:endParaRPr/>
+          </a:p>
           <a:p>
             <a:r>
               <a:t># Examples:</a:t>
@@ -3966,7 +4276,7 @@
 </file>
 
 <file path=ppt/slides/slide13.xml><?xml version="1.0" encoding="utf-8"?>
-<p:sld xmlns:a="http://schemas.openxmlformats.org/drawingml/2006/main" xmlns:p="http://schemas.openxmlformats.org/presentationml/2006/main" xmlns:r="http://schemas.openxmlformats.org/officeDocument/2006/relationships">
+<p:sld xmlns:a="http://schemas.openxmlformats.org/drawingml/2006/main" xmlns:r="http://schemas.openxmlformats.org/officeDocument/2006/relationships" xmlns:p="http://schemas.openxmlformats.org/presentationml/2006/main">
   <p:cSld>
     <p:bg>
       <p:bgPr>
@@ -3982,7 +4292,14 @@
         <p:cNvGrpSpPr/>
         <p:nvPr/>
       </p:nvGrpSpPr>
-      <p:grpSpPr/>
+      <p:grpSpPr>
+        <a:xfrm>
+          <a:off x="0" y="0"/>
+          <a:ext cx="0" cy="0"/>
+          <a:chOff x="0" y="0"/>
+          <a:chExt cx="0" cy="0"/>
+        </a:xfrm>
+      </p:grpSpPr>
       <p:sp>
         <p:nvSpPr>
           <p:cNvPr id="2" name="TextBox 1"/>
@@ -4058,6 +4375,7 @@
           <a:lstStyle/>
           <a:p>
             <a:pPr algn="ctr"/>
+            <a:endParaRPr/>
           </a:p>
         </p:txBody>
       </p:sp>
@@ -4134,64 +4452,117 @@
           </a:fontRef>
         </p:style>
         <p:txBody>
-          <a:bodyPr rtlCol="0" anchor="ctr" wrap="square"/>
-          <a:lstStyle/>
-          <a:p>
-            <a:r>
+          <a:bodyPr wrap="square" rtlCol="0" anchor="ctr"/>
+          <a:lstStyle/>
+          <a:p>
+            <a:r>
+              <a:rPr dirty="0"/>
               <a:t># From car-rental-microservices repository root</a:t>
             </a:r>
           </a:p>
           <a:p>
             <a:r>
+              <a:rPr dirty="0"/>
               <a:t>cd Webapp\services\platform-health</a:t>
             </a:r>
           </a:p>
-          <a:p/>
-          <a:p>
-            <a:r>
+          <a:p>
+            <a:endParaRPr dirty="0"/>
+          </a:p>
+          <a:p>
+            <a:r>
+              <a:rPr dirty="0"/>
               <a:t># Create an isolated Python environment for this service.</a:t>
             </a:r>
           </a:p>
           <a:p>
             <a:r>
-              <a:t>python -m venv .venv</a:t>
-            </a:r>
-          </a:p>
-          <a:p/>
-          <a:p>
-            <a:r>
+              <a:rPr dirty="0"/>
+              <a:t>python -m </a:t>
+            </a:r>
+            <a:r>
+              <a:rPr dirty="0" err="1"/>
+              <a:t>venv</a:t>
+            </a:r>
+            <a:r>
+              <a:rPr dirty="0"/>
+              <a:t> .</a:t>
+            </a:r>
+            <a:r>
+              <a:rPr dirty="0" err="1"/>
+              <a:t>venv</a:t>
+            </a:r>
+            <a:endParaRPr dirty="0"/>
+          </a:p>
+          <a:p>
+            <a:endParaRPr dirty="0"/>
+          </a:p>
+          <a:p>
+            <a:r>
+              <a:rPr dirty="0"/>
               <a:t># Activate it in PowerShell.</a:t>
             </a:r>
           </a:p>
           <a:p>
             <a:r>
-              <a:t>.\.venv\Scripts\Activate.ps1</a:t>
-            </a:r>
-          </a:p>
-          <a:p/>
-          <a:p>
-            <a:r>
+              <a:rPr lang="en-US" dirty="0"/>
+              <a:t>source .</a:t>
+            </a:r>
+            <a:r>
+              <a:rPr lang="en-US" dirty="0" err="1"/>
+              <a:t>venv</a:t>
+            </a:r>
+            <a:r>
+              <a:rPr lang="en-US" dirty="0"/>
+              <a:t>/Scripts/activate</a:t>
+            </a:r>
+          </a:p>
+          <a:p>
+            <a:endParaRPr dirty="0"/>
+          </a:p>
+          <a:p>
+            <a:r>
+              <a:rPr dirty="0"/>
               <a:t># Upgrade pip and install the web framework/server.</a:t>
             </a:r>
           </a:p>
           <a:p>
             <a:r>
+              <a:rPr dirty="0"/>
               <a:t>python -m pip install --upgrade pip</a:t>
             </a:r>
           </a:p>
           <a:p>
             <a:r>
-              <a:t>pip install fastapi uvicorn</a:t>
-            </a:r>
-          </a:p>
-          <a:p/>
-          <a:p>
-            <a:r>
+              <a:rPr dirty="0"/>
+              <a:t>pip install </a:t>
+            </a:r>
+            <a:r>
+              <a:rPr dirty="0" err="1"/>
+              <a:t>fastapi</a:t>
+            </a:r>
+            <a:r>
+              <a:rPr dirty="0"/>
+              <a:t> </a:t>
+            </a:r>
+            <a:r>
+              <a:rPr dirty="0" err="1"/>
+              <a:t>uvicorn</a:t>
+            </a:r>
+            <a:endParaRPr dirty="0"/>
+          </a:p>
+          <a:p>
+            <a:endParaRPr dirty="0"/>
+          </a:p>
+          <a:p>
+            <a:r>
+              <a:rPr dirty="0"/>
               <a:t># Confirm installed packages.</a:t>
             </a:r>
           </a:p>
           <a:p>
             <a:r>
+              <a:rPr dirty="0"/>
               <a:t>pip list</a:t>
             </a:r>
           </a:p>
@@ -4206,7 +4577,7 @@
 </file>
 
 <file path=ppt/slides/slide14.xml><?xml version="1.0" encoding="utf-8"?>
-<p:sld xmlns:a="http://schemas.openxmlformats.org/drawingml/2006/main" xmlns:p="http://schemas.openxmlformats.org/presentationml/2006/main" xmlns:r="http://schemas.openxmlformats.org/officeDocument/2006/relationships">
+<p:sld xmlns:a="http://schemas.openxmlformats.org/drawingml/2006/main" xmlns:r="http://schemas.openxmlformats.org/officeDocument/2006/relationships" xmlns:p="http://schemas.openxmlformats.org/presentationml/2006/main">
   <p:cSld>
     <p:bg>
       <p:bgPr>
@@ -4222,7 +4593,14 @@
         <p:cNvGrpSpPr/>
         <p:nvPr/>
       </p:nvGrpSpPr>
-      <p:grpSpPr/>
+      <p:grpSpPr>
+        <a:xfrm>
+          <a:off x="0" y="0"/>
+          <a:ext cx="0" cy="0"/>
+          <a:chOff x="0" y="0"/>
+          <a:chExt cx="0" cy="0"/>
+        </a:xfrm>
+      </p:grpSpPr>
       <p:sp>
         <p:nvSpPr>
           <p:cNvPr id="2" name="TextBox 1"/>
@@ -4333,6 +4711,7 @@
           <a:lstStyle/>
           <a:p>
             <a:pPr algn="ctr"/>
+            <a:endParaRPr/>
           </a:p>
         </p:txBody>
       </p:sp>
@@ -4379,7 +4758,7 @@
         </p:nvSpPr>
         <p:spPr>
           <a:xfrm>
-            <a:off x="731520" y="1325880"/>
+            <a:off x="652272" y="969264"/>
             <a:ext cx="10789920" cy="5074920"/>
           </a:xfrm>
           <a:prstGeom prst="roundRect">
@@ -4409,118 +4788,339 @@
           </a:fontRef>
         </p:style>
         <p:txBody>
-          <a:bodyPr rtlCol="0" anchor="ctr" wrap="square"/>
-          <a:lstStyle/>
-          <a:p>
-            <a:r>
-              <a:t>from fastapi import FastAPI</a:t>
-            </a:r>
-          </a:p>
-          <a:p/>
-          <a:p>
-            <a:r>
-              <a:t># Create the FastAPI application object.</a:t>
-            </a:r>
-          </a:p>
-          <a:p>
-            <a:r>
-              <a:t># Uvicorn loads this object and exposes it over HTTP.</a:t>
-            </a:r>
-          </a:p>
-          <a:p>
-            <a:r>
-              <a:t>app = FastAPI(</a:t>
-            </a:r>
-          </a:p>
-          <a:p>
-            <a:r>
+          <a:bodyPr wrap="square" rtlCol="0" anchor="ctr"/>
+          <a:lstStyle/>
+          <a:p>
+            <a:r>
+              <a:rPr dirty="0">
+                <a:highlight>
+                  <a:srgbClr val="000080"/>
+                </a:highlight>
+              </a:rPr>
+              <a:t>from </a:t>
+            </a:r>
+            <a:r>
+              <a:rPr dirty="0" err="1">
+                <a:highlight>
+                  <a:srgbClr val="000080"/>
+                </a:highlight>
+              </a:rPr>
+              <a:t>fastapi</a:t>
+            </a:r>
+            <a:r>
+              <a:rPr dirty="0">
+                <a:highlight>
+                  <a:srgbClr val="000080"/>
+                </a:highlight>
+              </a:rPr>
+              <a:t> import </a:t>
+            </a:r>
+            <a:r>
+              <a:rPr dirty="0" err="1">
+                <a:highlight>
+                  <a:srgbClr val="000080"/>
+                </a:highlight>
+              </a:rPr>
+              <a:t>FastAPI</a:t>
+            </a:r>
+            <a:endParaRPr dirty="0">
+              <a:highlight>
+                <a:srgbClr val="000080"/>
+              </a:highlight>
+            </a:endParaRPr>
+          </a:p>
+          <a:p>
+            <a:endParaRPr dirty="0">
+              <a:highlight>
+                <a:srgbClr val="000080"/>
+              </a:highlight>
+            </a:endParaRPr>
+          </a:p>
+          <a:p>
+            <a:r>
+              <a:rPr dirty="0">
+                <a:highlight>
+                  <a:srgbClr val="000080"/>
+                </a:highlight>
+              </a:rPr>
+              <a:t># Create the </a:t>
+            </a:r>
+            <a:r>
+              <a:rPr dirty="0" err="1">
+                <a:highlight>
+                  <a:srgbClr val="000080"/>
+                </a:highlight>
+              </a:rPr>
+              <a:t>FastAPI</a:t>
+            </a:r>
+            <a:r>
+              <a:rPr dirty="0">
+                <a:highlight>
+                  <a:srgbClr val="000080"/>
+                </a:highlight>
+              </a:rPr>
+              <a:t> application object.</a:t>
+            </a:r>
+          </a:p>
+          <a:p>
+            <a:r>
+              <a:rPr dirty="0">
+                <a:highlight>
+                  <a:srgbClr val="000080"/>
+                </a:highlight>
+              </a:rPr>
+              <a:t># </a:t>
+            </a:r>
+            <a:r>
+              <a:rPr dirty="0" err="1">
+                <a:highlight>
+                  <a:srgbClr val="000080"/>
+                </a:highlight>
+              </a:rPr>
+              <a:t>Uvicorn</a:t>
+            </a:r>
+            <a:r>
+              <a:rPr dirty="0">
+                <a:highlight>
+                  <a:srgbClr val="000080"/>
+                </a:highlight>
+              </a:rPr>
+              <a:t> loads this object and exposes it over HTTP.</a:t>
+            </a:r>
+          </a:p>
+          <a:p>
+            <a:r>
+              <a:rPr dirty="0">
+                <a:highlight>
+                  <a:srgbClr val="000080"/>
+                </a:highlight>
+              </a:rPr>
+              <a:t>app = </a:t>
+            </a:r>
+            <a:r>
+              <a:rPr dirty="0" err="1">
+                <a:highlight>
+                  <a:srgbClr val="000080"/>
+                </a:highlight>
+              </a:rPr>
+              <a:t>FastAPI</a:t>
+            </a:r>
+            <a:r>
+              <a:rPr dirty="0">
+                <a:highlight>
+                  <a:srgbClr val="000080"/>
+                </a:highlight>
+              </a:rPr>
+              <a:t>(</a:t>
+            </a:r>
+          </a:p>
+          <a:p>
+            <a:r>
+              <a:rPr dirty="0">
+                <a:highlight>
+                  <a:srgbClr val="000080"/>
+                </a:highlight>
+              </a:rPr>
               <a:t>    title="Car Rental Platform Health Service",</a:t>
             </a:r>
           </a:p>
           <a:p>
             <a:r>
+              <a:rPr dirty="0">
+                <a:highlight>
+                  <a:srgbClr val="000080"/>
+                </a:highlight>
+              </a:rPr>
               <a:t>    description="Project 1 development environment test.",</a:t>
             </a:r>
           </a:p>
           <a:p>
             <a:r>
+              <a:rPr dirty="0">
+                <a:highlight>
+                  <a:srgbClr val="000080"/>
+                </a:highlight>
+              </a:rPr>
               <a:t>    version="1.0.0",</a:t>
             </a:r>
           </a:p>
           <a:p>
             <a:r>
+              <a:rPr dirty="0">
+                <a:highlight>
+                  <a:srgbClr val="000080"/>
+                </a:highlight>
+              </a:rPr>
               <a:t>)</a:t>
             </a:r>
           </a:p>
-          <a:p/>
-          <a:p>
-            <a:r>
+          <a:p>
+            <a:endParaRPr dirty="0">
+              <a:highlight>
+                <a:srgbClr val="000080"/>
+              </a:highlight>
+            </a:endParaRPr>
+          </a:p>
+          <a:p>
+            <a:r>
+              <a:rPr dirty="0">
+                <a:highlight>
+                  <a:srgbClr val="000080"/>
+                </a:highlight>
+              </a:rPr>
               <a:t># GET / proves the API itself is responding.</a:t>
             </a:r>
           </a:p>
           <a:p>
             <a:r>
+              <a:rPr dirty="0">
+                <a:highlight>
+                  <a:srgbClr val="000080"/>
+                </a:highlight>
+              </a:rPr>
               <a:t>@app.get("/")</a:t>
             </a:r>
           </a:p>
           <a:p>
             <a:r>
+              <a:rPr dirty="0">
+                <a:highlight>
+                  <a:srgbClr val="000080"/>
+                </a:highlight>
+              </a:rPr>
               <a:t>def root():</a:t>
             </a:r>
           </a:p>
           <a:p>
             <a:r>
+              <a:rPr dirty="0">
+                <a:highlight>
+                  <a:srgbClr val="000080"/>
+                </a:highlight>
+              </a:rPr>
               <a:t>    return {</a:t>
             </a:r>
           </a:p>
           <a:p>
             <a:r>
+              <a:rPr dirty="0">
+                <a:highlight>
+                  <a:srgbClr val="000080"/>
+                </a:highlight>
+              </a:rPr>
               <a:t>        "application": "car-rental-microservices",</a:t>
             </a:r>
           </a:p>
           <a:p>
             <a:r>
+              <a:rPr dirty="0">
+                <a:highlight>
+                  <a:srgbClr val="000080"/>
+                </a:highlight>
+              </a:rPr>
               <a:t>        "message": "Car Rental Platform API is running",</a:t>
             </a:r>
           </a:p>
           <a:p>
             <a:r>
+              <a:rPr dirty="0">
+                <a:highlight>
+                  <a:srgbClr val="000080"/>
+                </a:highlight>
+              </a:rPr>
               <a:t>    }</a:t>
             </a:r>
           </a:p>
-          <a:p/>
-          <a:p>
-            <a:r>
+          <a:p>
+            <a:endParaRPr dirty="0">
+              <a:highlight>
+                <a:srgbClr val="000080"/>
+              </a:highlight>
+            </a:endParaRPr>
+          </a:p>
+          <a:p>
+            <a:r>
+              <a:rPr dirty="0">
+                <a:highlight>
+                  <a:srgbClr val="000080"/>
+                </a:highlight>
+              </a:rPr>
               <a:t># GET /health proves the service is alive and responding.</a:t>
             </a:r>
           </a:p>
           <a:p>
             <a:r>
+              <a:rPr dirty="0">
+                <a:highlight>
+                  <a:srgbClr val="000080"/>
+                </a:highlight>
+              </a:rPr>
               <a:t>@app.get("/health")</a:t>
             </a:r>
           </a:p>
           <a:p>
             <a:r>
-              <a:t>def health_check():</a:t>
-            </a:r>
-          </a:p>
-          <a:p>
-            <a:r>
+              <a:rPr dirty="0">
+                <a:highlight>
+                  <a:srgbClr val="000080"/>
+                </a:highlight>
+              </a:rPr>
+              <a:t>def </a:t>
+            </a:r>
+            <a:r>
+              <a:rPr dirty="0" err="1">
+                <a:highlight>
+                  <a:srgbClr val="000080"/>
+                </a:highlight>
+              </a:rPr>
+              <a:t>health_check</a:t>
+            </a:r>
+            <a:r>
+              <a:rPr dirty="0">
+                <a:highlight>
+                  <a:srgbClr val="000080"/>
+                </a:highlight>
+              </a:rPr>
+              <a:t>():</a:t>
+            </a:r>
+          </a:p>
+          <a:p>
+            <a:r>
+              <a:rPr dirty="0">
+                <a:highlight>
+                  <a:srgbClr val="000080"/>
+                </a:highlight>
+              </a:rPr>
               <a:t>    return {</a:t>
             </a:r>
           </a:p>
           <a:p>
             <a:r>
+              <a:rPr dirty="0">
+                <a:highlight>
+                  <a:srgbClr val="000080"/>
+                </a:highlight>
+              </a:rPr>
               <a:t>        "status": "healthy",</a:t>
             </a:r>
           </a:p>
           <a:p>
             <a:r>
+              <a:rPr dirty="0">
+                <a:highlight>
+                  <a:srgbClr val="000080"/>
+                </a:highlight>
+              </a:rPr>
               <a:t>        "service": "platform-health",</a:t>
             </a:r>
           </a:p>
           <a:p>
             <a:r>
+              <a:rPr dirty="0">
+                <a:highlight>
+                  <a:srgbClr val="000080"/>
+                </a:highlight>
+              </a:rPr>
               <a:t>    }</a:t>
             </a:r>
           </a:p>
@@ -4535,7 +5135,7 @@
 </file>
 
 <file path=ppt/slides/slide15.xml><?xml version="1.0" encoding="utf-8"?>
-<p:sld xmlns:a="http://schemas.openxmlformats.org/drawingml/2006/main" xmlns:p="http://schemas.openxmlformats.org/presentationml/2006/main" xmlns:r="http://schemas.openxmlformats.org/officeDocument/2006/relationships">
+<p:sld xmlns:a="http://schemas.openxmlformats.org/drawingml/2006/main" xmlns:r="http://schemas.openxmlformats.org/officeDocument/2006/relationships" xmlns:p="http://schemas.openxmlformats.org/presentationml/2006/main">
   <p:cSld>
     <p:bg>
       <p:bgPr>
@@ -4551,7 +5151,14 @@
         <p:cNvGrpSpPr/>
         <p:nvPr/>
       </p:nvGrpSpPr>
-      <p:grpSpPr/>
+      <p:grpSpPr>
+        <a:xfrm>
+          <a:off x="0" y="0"/>
+          <a:ext cx="0" cy="0"/>
+          <a:chOff x="0" y="0"/>
+          <a:chExt cx="0" cy="0"/>
+        </a:xfrm>
+      </p:grpSpPr>
       <p:sp>
         <p:nvSpPr>
           <p:cNvPr id="2" name="TextBox 1"/>
@@ -4627,6 +5234,7 @@
           <a:lstStyle/>
           <a:p>
             <a:pPr algn="ctr"/>
+            <a:endParaRPr/>
           </a:p>
         </p:txBody>
       </p:sp>
@@ -4703,7 +5311,7 @@
           </a:fontRef>
         </p:style>
         <p:txBody>
-          <a:bodyPr rtlCol="0" anchor="ctr" wrap="square"/>
+          <a:bodyPr wrap="square" rtlCol="0" anchor="ctr"/>
           <a:lstStyle/>
           <a:p>
             <a:pPr algn="ctr">
@@ -4715,37 +5323,99 @@
               </a:defRPr>
             </a:pPr>
             <a:r>
-              <a:t>uvicorn main:app --reload</a:t>
-            </a:r>
-            <a:br/>
-            <a:br/>
-            <a:r>
+              <a:rPr dirty="0" err="1"/>
+              <a:t>uvicorn</a:t>
+            </a:r>
+            <a:r>
+              <a:rPr dirty="0"/>
+              <a:t> </a:t>
+            </a:r>
+            <a:r>
+              <a:rPr dirty="0" err="1"/>
+              <a:t>main:app</a:t>
+            </a:r>
+            <a:r>
+              <a:rPr dirty="0"/>
+              <a:t> --reload</a:t>
+            </a:r>
+            <a:br>
+              <a:rPr dirty="0"/>
+            </a:br>
+            <a:br>
+              <a:rPr dirty="0"/>
+            </a:br>
+            <a:r>
+              <a:rPr dirty="0"/>
               <a:t># Meaning:</a:t>
             </a:r>
-            <a:br/>
-            <a:r>
-              <a:t># uvicorn  -&gt; ASGI web server</a:t>
-            </a:r>
-            <a:br/>
-            <a:r>
+            <a:br>
+              <a:rPr dirty="0"/>
+            </a:br>
+            <a:r>
+              <a:rPr dirty="0"/>
+              <a:t># </a:t>
+            </a:r>
+            <a:r>
+              <a:rPr dirty="0" err="1"/>
+              <a:t>uvicorn</a:t>
+            </a:r>
+            <a:r>
+              <a:rPr dirty="0"/>
+              <a:t>  -&gt; ASGI web server</a:t>
+            </a:r>
+            <a:br>
+              <a:rPr dirty="0"/>
+            </a:br>
+            <a:r>
+              <a:rPr dirty="0"/>
               <a:t># main     -&gt; main.py</a:t>
             </a:r>
-            <a:br/>
-            <a:r>
-              <a:t># app      -&gt; FastAPI object named "app"</a:t>
-            </a:r>
-            <a:br/>
-            <a:r>
+            <a:br>
+              <a:rPr dirty="0"/>
+            </a:br>
+            <a:r>
+              <a:rPr dirty="0"/>
+              <a:t># app      -&gt; </a:t>
+            </a:r>
+            <a:r>
+              <a:rPr dirty="0" err="1"/>
+              <a:t>FastAPI</a:t>
+            </a:r>
+            <a:r>
+              <a:rPr dirty="0"/>
+              <a:t> object named "app"</a:t>
+            </a:r>
+            <a:br>
+              <a:rPr dirty="0"/>
+            </a:br>
+            <a:r>
+              <a:rPr dirty="0"/>
               <a:t># --reload -&gt; automatically restart after code changes</a:t>
             </a:r>
-            <a:br/>
-            <a:br/>
-            <a:r>
+            <a:br>
+              <a:rPr dirty="0"/>
+            </a:br>
+            <a:br>
+              <a:rPr dirty="0"/>
+            </a:br>
+            <a:r>
+              <a:rPr dirty="0"/>
               <a:t># Expected:</a:t>
             </a:r>
-            <a:br/>
-            <a:r>
-              <a:t># Uvicorn running on http://127.0.0.1:8000</a:t>
+            <a:br>
+              <a:rPr dirty="0"/>
+            </a:br>
+            <a:r>
+              <a:rPr dirty="0"/>
+              <a:t># </a:t>
+            </a:r>
+            <a:r>
+              <a:rPr dirty="0" err="1"/>
+              <a:t>Uvicorn</a:t>
+            </a:r>
+            <a:r>
+              <a:rPr dirty="0"/>
+              <a:t> running on http://127.0.0.1:8000</a:t>
             </a:r>
           </a:p>
         </p:txBody>
@@ -4797,7 +5467,7 @@
 </file>
 
 <file path=ppt/slides/slide16.xml><?xml version="1.0" encoding="utf-8"?>
-<p:sld xmlns:a="http://schemas.openxmlformats.org/drawingml/2006/main" xmlns:p="http://schemas.openxmlformats.org/presentationml/2006/main" xmlns:r="http://schemas.openxmlformats.org/officeDocument/2006/relationships">
+<p:sld xmlns:a="http://schemas.openxmlformats.org/drawingml/2006/main" xmlns:r="http://schemas.openxmlformats.org/officeDocument/2006/relationships" xmlns:p="http://schemas.openxmlformats.org/presentationml/2006/main">
   <p:cSld>
     <p:bg>
       <p:bgPr>
@@ -4813,7 +5483,14 @@
         <p:cNvGrpSpPr/>
         <p:nvPr/>
       </p:nvGrpSpPr>
-      <p:grpSpPr/>
+      <p:grpSpPr>
+        <a:xfrm>
+          <a:off x="0" y="0"/>
+          <a:ext cx="0" cy="0"/>
+          <a:chOff x="0" y="0"/>
+          <a:chExt cx="0" cy="0"/>
+        </a:xfrm>
+      </p:grpSpPr>
       <p:sp>
         <p:nvSpPr>
           <p:cNvPr id="2" name="TextBox 1"/>
@@ -4889,6 +5566,7 @@
           <a:lstStyle/>
           <a:p>
             <a:pPr algn="ctr"/>
+            <a:endParaRPr/>
           </a:p>
         </p:txBody>
       </p:sp>
@@ -4960,6 +5638,7 @@
               </a:defRPr>
             </a:pPr>
             <a:r>
+              <a:rPr dirty="0"/>
               <a:t>Open http://127.0.0.1:8000 — verify the root JSON response.</a:t>
             </a:r>
           </a:p>
@@ -4975,6 +5654,7 @@
               </a:defRPr>
             </a:pPr>
             <a:r>
+              <a:rPr dirty="0"/>
               <a:t>Open http://127.0.0.1:8000/health — verify status = healthy.</a:t>
             </a:r>
           </a:p>
@@ -4990,7 +5670,24 @@
               </a:defRPr>
             </a:pPr>
             <a:r>
-              <a:t>Open http://127.0.0.1:8000/docs — FastAPI automatically generates Swagger/OpenAPI documentation.</a:t>
+              <a:rPr dirty="0"/>
+              <a:t>Open http://127.0.0.1:8000/docs — </a:t>
+            </a:r>
+            <a:r>
+              <a:rPr dirty="0" err="1"/>
+              <a:t>FastAPI</a:t>
+            </a:r>
+            <a:r>
+              <a:rPr dirty="0"/>
+              <a:t> automatically generates Swagger/</a:t>
+            </a:r>
+            <a:r>
+              <a:rPr dirty="0" err="1"/>
+              <a:t>OpenAPI</a:t>
+            </a:r>
+            <a:r>
+              <a:rPr dirty="0"/>
+              <a:t> documentation.</a:t>
             </a:r>
           </a:p>
           <a:p>
@@ -5005,6 +5702,7 @@
               </a:defRPr>
             </a:pPr>
             <a:r>
+              <a:rPr dirty="0"/>
               <a:t>Select GET /health → Try it out → Execute.</a:t>
             </a:r>
           </a:p>
@@ -5020,6 +5718,7 @@
               </a:defRPr>
             </a:pPr>
             <a:r>
+              <a:rPr dirty="0"/>
               <a:t>Expected HTTP status: 200 OK.</a:t>
             </a:r>
           </a:p>
@@ -5034,7 +5733,7 @@
 </file>
 
 <file path=ppt/slides/slide17.xml><?xml version="1.0" encoding="utf-8"?>
-<p:sld xmlns:a="http://schemas.openxmlformats.org/drawingml/2006/main" xmlns:p="http://schemas.openxmlformats.org/presentationml/2006/main" xmlns:r="http://schemas.openxmlformats.org/officeDocument/2006/relationships">
+<p:sld xmlns:a="http://schemas.openxmlformats.org/drawingml/2006/main" xmlns:r="http://schemas.openxmlformats.org/officeDocument/2006/relationships" xmlns:p="http://schemas.openxmlformats.org/presentationml/2006/main">
   <p:cSld>
     <p:bg>
       <p:bgPr>
@@ -5050,7 +5749,14 @@
         <p:cNvGrpSpPr/>
         <p:nvPr/>
       </p:nvGrpSpPr>
-      <p:grpSpPr/>
+      <p:grpSpPr>
+        <a:xfrm>
+          <a:off x="0" y="0"/>
+          <a:ext cx="0" cy="0"/>
+          <a:chOff x="0" y="0"/>
+          <a:chExt cx="0" cy="0"/>
+        </a:xfrm>
+      </p:grpSpPr>
       <p:sp>
         <p:nvSpPr>
           <p:cNvPr id="2" name="TextBox 1"/>
@@ -5126,6 +5832,7 @@
           <a:lstStyle/>
           <a:p>
             <a:pPr algn="ctr"/>
+            <a:endParaRPr/>
           </a:p>
         </p:txBody>
       </p:sp>
@@ -5202,7 +5909,7 @@
           </a:fontRef>
         </p:style>
         <p:txBody>
-          <a:bodyPr rtlCol="0" anchor="ctr" wrap="square"/>
+          <a:bodyPr wrap="square" rtlCol="0" anchor="ctr"/>
           <a:lstStyle/>
           <a:p>
             <a:pPr algn="ctr">
@@ -5214,37 +5921,73 @@
               </a:defRPr>
             </a:pPr>
             <a:r>
+              <a:rPr dirty="0"/>
               <a:t># Test the endpoint without a browser.</a:t>
             </a:r>
-            <a:br/>
-            <a:r>
+            <a:br>
+              <a:rPr dirty="0"/>
+            </a:br>
+            <a:r>
+              <a:rPr dirty="0"/>
               <a:t>curl.exe http://127.0.0.1:8000/health</a:t>
             </a:r>
-            <a:br/>
-            <a:br/>
-            <a:r>
+            <a:br>
+              <a:rPr dirty="0"/>
+            </a:br>
+            <a:br>
+              <a:rPr dirty="0"/>
+            </a:br>
+            <a:r>
+              <a:rPr dirty="0"/>
               <a:t># Capture exact Python dependencies.</a:t>
             </a:r>
-            <a:br/>
-            <a:r>
+            <a:br>
+              <a:rPr dirty="0"/>
+            </a:br>
+            <a:r>
+              <a:rPr dirty="0"/>
               <a:t>pip freeze &gt; requirements.txt</a:t>
             </a:r>
-            <a:br/>
-            <a:br/>
-            <a:r>
-              <a:t># Stop Uvicorn.</a:t>
-            </a:r>
-            <a:br/>
-            <a:r>
+            <a:br>
+              <a:rPr dirty="0"/>
+            </a:br>
+            <a:br>
+              <a:rPr dirty="0"/>
+            </a:br>
+            <a:r>
+              <a:rPr dirty="0"/>
+              <a:t># Stop </a:t>
+            </a:r>
+            <a:r>
+              <a:rPr dirty="0" err="1"/>
+              <a:t>Uvicorn</a:t>
+            </a:r>
+            <a:r>
+              <a:rPr dirty="0"/>
+              <a:t>.</a:t>
+            </a:r>
+            <a:br>
+              <a:rPr dirty="0"/>
+            </a:br>
+            <a:r>
+              <a:rPr dirty="0"/>
               <a:t>CTRL + C</a:t>
             </a:r>
-            <a:br/>
-            <a:br/>
-            <a:r>
+            <a:br>
+              <a:rPr dirty="0"/>
+            </a:br>
+            <a:br>
+              <a:rPr dirty="0"/>
+            </a:br>
+            <a:r>
+              <a:rPr dirty="0"/>
               <a:t># Leave the virtual environment.</a:t>
             </a:r>
-            <a:br/>
-            <a:r>
+            <a:br>
+              <a:rPr dirty="0"/>
+            </a:br>
+            <a:r>
+              <a:rPr dirty="0"/>
               <a:t>deactivate</a:t>
             </a:r>
           </a:p>
@@ -5297,7 +6040,7 @@
 </file>
 
 <file path=ppt/slides/slide18.xml><?xml version="1.0" encoding="utf-8"?>
-<p:sld xmlns:a="http://schemas.openxmlformats.org/drawingml/2006/main" xmlns:p="http://schemas.openxmlformats.org/presentationml/2006/main" xmlns:r="http://schemas.openxmlformats.org/officeDocument/2006/relationships">
+<p:sld xmlns:a="http://schemas.openxmlformats.org/drawingml/2006/main" xmlns:r="http://schemas.openxmlformats.org/officeDocument/2006/relationships" xmlns:p="http://schemas.openxmlformats.org/presentationml/2006/main">
   <p:cSld>
     <p:bg>
       <p:bgPr>
@@ -5313,7 +6056,14 @@
         <p:cNvGrpSpPr/>
         <p:nvPr/>
       </p:nvGrpSpPr>
-      <p:grpSpPr/>
+      <p:grpSpPr>
+        <a:xfrm>
+          <a:off x="0" y="0"/>
+          <a:ext cx="0" cy="0"/>
+          <a:chOff x="0" y="0"/>
+          <a:chExt cx="0" cy="0"/>
+        </a:xfrm>
+      </p:grpSpPr>
       <p:sp>
         <p:nvSpPr>
           <p:cNvPr id="2" name="TextBox 1"/>
@@ -5389,6 +6139,7 @@
           <a:lstStyle/>
           <a:p>
             <a:pPr algn="ctr"/>
+            <a:endParaRPr/>
           </a:p>
         </p:txBody>
       </p:sp>
@@ -5465,91 +6216,268 @@
           </a:fontRef>
         </p:style>
         <p:txBody>
-          <a:bodyPr rtlCol="0" anchor="ctr" wrap="square"/>
-          <a:lstStyle/>
-          <a:p>
-            <a:r>
+          <a:bodyPr wrap="square" rtlCol="0" anchor="ctr"/>
+          <a:lstStyle/>
+          <a:p>
+            <a:r>
+              <a:rPr dirty="0">
+                <a:highlight>
+                  <a:srgbClr val="000080"/>
+                </a:highlight>
+              </a:rPr>
               <a:t># Return to repository root from Webapp\services\platform-health</a:t>
             </a:r>
           </a:p>
           <a:p>
             <a:r>
+              <a:rPr dirty="0">
+                <a:highlight>
+                  <a:srgbClr val="000080"/>
+                </a:highlight>
+              </a:rPr>
               <a:t>cd ..\..\..</a:t>
             </a:r>
           </a:p>
-          <a:p/>
-          <a:p>
-            <a:r>
+          <a:p>
+            <a:endParaRPr dirty="0">
+              <a:highlight>
+                <a:srgbClr val="000080"/>
+              </a:highlight>
+            </a:endParaRPr>
+          </a:p>
+          <a:p>
+            <a:r>
+              <a:rPr dirty="0">
+                <a:highlight>
+                  <a:srgbClr val="000080"/>
+                </a:highlight>
+              </a:rPr>
               <a:t># Confirm repository root</a:t>
             </a:r>
           </a:p>
           <a:p>
             <a:r>
-              <a:t>git rev-parse --show-toplevel</a:t>
-            </a:r>
-          </a:p>
-          <a:p/>
-          <a:p>
-            <a:r>
-              <a:t># Verify .venv and Office temp files are NOT being tracked.</a:t>
-            </a:r>
-          </a:p>
-          <a:p>
-            <a:r>
+              <a:rPr dirty="0">
+                <a:highlight>
+                  <a:srgbClr val="000080"/>
+                </a:highlight>
+              </a:rPr>
+              <a:t>git rev-parse --show-</a:t>
+            </a:r>
+            <a:r>
+              <a:rPr dirty="0" err="1">
+                <a:highlight>
+                  <a:srgbClr val="000080"/>
+                </a:highlight>
+              </a:rPr>
+              <a:t>toplevel</a:t>
+            </a:r>
+            <a:endParaRPr dirty="0">
+              <a:highlight>
+                <a:srgbClr val="000080"/>
+              </a:highlight>
+            </a:endParaRPr>
+          </a:p>
+          <a:p>
+            <a:endParaRPr dirty="0">
+              <a:highlight>
+                <a:srgbClr val="000080"/>
+              </a:highlight>
+            </a:endParaRPr>
+          </a:p>
+          <a:p>
+            <a:r>
+              <a:rPr dirty="0">
+                <a:highlight>
+                  <a:srgbClr val="000080"/>
+                </a:highlight>
+              </a:rPr>
+              <a:t># Verify .</a:t>
+            </a:r>
+            <a:r>
+              <a:rPr dirty="0" err="1">
+                <a:highlight>
+                  <a:srgbClr val="000080"/>
+                </a:highlight>
+              </a:rPr>
+              <a:t>venv</a:t>
+            </a:r>
+            <a:r>
+              <a:rPr dirty="0">
+                <a:highlight>
+                  <a:srgbClr val="000080"/>
+                </a:highlight>
+              </a:rPr>
+              <a:t> and Office temp files are NOT being tracked.</a:t>
+            </a:r>
+          </a:p>
+          <a:p>
+            <a:r>
+              <a:rPr dirty="0">
+                <a:highlight>
+                  <a:srgbClr val="000080"/>
+                </a:highlight>
+              </a:rPr>
               <a:t>git status</a:t>
             </a:r>
           </a:p>
-          <a:p/>
-          <a:p>
-            <a:r>
+          <a:p>
+            <a:endParaRPr dirty="0">
+              <a:highlight>
+                <a:srgbClr val="000080"/>
+              </a:highlight>
+            </a:endParaRPr>
+          </a:p>
+          <a:p>
+            <a:r>
+              <a:rPr dirty="0">
+                <a:highlight>
+                  <a:srgbClr val="000080"/>
+                </a:highlight>
+              </a:rPr>
               <a:t># Stage Project 1 learning material and the Webapp foundation intentionally.</a:t>
             </a:r>
           </a:p>
           <a:p>
             <a:r>
-              <a:t>git add LearningPath\Project-01-Foundation</a:t>
-            </a:r>
-          </a:p>
-          <a:p>
-            <a:r>
+              <a:rPr dirty="0">
+                <a:highlight>
+                  <a:srgbClr val="000080"/>
+                </a:highlight>
+              </a:rPr>
+              <a:t>git add </a:t>
+            </a:r>
+            <a:r>
+              <a:rPr dirty="0" err="1">
+                <a:highlight>
+                  <a:srgbClr val="000080"/>
+                </a:highlight>
+              </a:rPr>
+              <a:t>LearningPath</a:t>
+            </a:r>
+            <a:r>
+              <a:rPr dirty="0">
+                <a:highlight>
+                  <a:srgbClr val="000080"/>
+                </a:highlight>
+              </a:rPr>
+              <a:t>\Project-01-Foundation</a:t>
+            </a:r>
+          </a:p>
+          <a:p>
+            <a:r>
+              <a:rPr dirty="0">
+                <a:highlight>
+                  <a:srgbClr val="000080"/>
+                </a:highlight>
+              </a:rPr>
               <a:t>git add Webapp</a:t>
             </a:r>
           </a:p>
           <a:p>
             <a:r>
-              <a:t>git add .gitignore README.md</a:t>
-            </a:r>
-          </a:p>
-          <a:p/>
-          <a:p>
-            <a:r>
+              <a:rPr dirty="0">
+                <a:highlight>
+                  <a:srgbClr val="000080"/>
+                </a:highlight>
+              </a:rPr>
+              <a:t>git add .</a:t>
+            </a:r>
+            <a:r>
+              <a:rPr dirty="0" err="1">
+                <a:highlight>
+                  <a:srgbClr val="000080"/>
+                </a:highlight>
+              </a:rPr>
+              <a:t>gitignore</a:t>
+            </a:r>
+            <a:r>
+              <a:rPr dirty="0">
+                <a:highlight>
+                  <a:srgbClr val="000080"/>
+                </a:highlight>
+              </a:rPr>
+              <a:t> README.md</a:t>
+            </a:r>
+          </a:p>
+          <a:p>
+            <a:endParaRPr dirty="0">
+              <a:highlight>
+                <a:srgbClr val="000080"/>
+              </a:highlight>
+            </a:endParaRPr>
+          </a:p>
+          <a:p>
+            <a:r>
+              <a:rPr dirty="0">
+                <a:highlight>
+                  <a:srgbClr val="000080"/>
+                </a:highlight>
+              </a:rPr>
               <a:t># Review exactly what will be committed.</a:t>
             </a:r>
           </a:p>
           <a:p>
             <a:r>
+              <a:rPr dirty="0">
+                <a:highlight>
+                  <a:srgbClr val="000080"/>
+                </a:highlight>
+              </a:rPr>
               <a:t>git status</a:t>
             </a:r>
           </a:p>
-          <a:p/>
-          <a:p>
-            <a:r>
+          <a:p>
+            <a:endParaRPr dirty="0">
+              <a:highlight>
+                <a:srgbClr val="000080"/>
+              </a:highlight>
+            </a:endParaRPr>
+          </a:p>
+          <a:p>
+            <a:r>
+              <a:rPr dirty="0">
+                <a:highlight>
+                  <a:srgbClr val="000080"/>
+                </a:highlight>
+              </a:rPr>
               <a:t># Create the Project 1 checkpoint.</a:t>
             </a:r>
           </a:p>
           <a:p>
             <a:r>
+              <a:rPr dirty="0">
+                <a:highlight>
+                  <a:srgbClr val="000080"/>
+                </a:highlight>
+              </a:rPr>
               <a:t>git commit -m "Complete Project 01 - microservices foundation"</a:t>
             </a:r>
           </a:p>
-          <a:p/>
-          <a:p>
-            <a:r>
+          <a:p>
+            <a:endParaRPr dirty="0">
+              <a:highlight>
+                <a:srgbClr val="000080"/>
+              </a:highlight>
+            </a:endParaRPr>
+          </a:p>
+          <a:p>
+            <a:r>
+              <a:rPr dirty="0">
+                <a:highlight>
+                  <a:srgbClr val="000080"/>
+                </a:highlight>
+              </a:rPr>
               <a:t># Standardize the primary branch name.</a:t>
             </a:r>
           </a:p>
           <a:p>
             <a:r>
+              <a:rPr dirty="0">
+                <a:highlight>
+                  <a:srgbClr val="000080"/>
+                </a:highlight>
+              </a:rPr>
               <a:t>git branch -M main</a:t>
             </a:r>
           </a:p>
@@ -5564,7 +6492,7 @@
 </file>
 
 <file path=ppt/slides/slide19.xml><?xml version="1.0" encoding="utf-8"?>
-<p:sld xmlns:a="http://schemas.openxmlformats.org/drawingml/2006/main" xmlns:p="http://schemas.openxmlformats.org/presentationml/2006/main" xmlns:r="http://schemas.openxmlformats.org/officeDocument/2006/relationships">
+<p:sld xmlns:a="http://schemas.openxmlformats.org/drawingml/2006/main" xmlns:r="http://schemas.openxmlformats.org/officeDocument/2006/relationships" xmlns:p="http://schemas.openxmlformats.org/presentationml/2006/main">
   <p:cSld>
     <p:bg>
       <p:bgPr>
@@ -5580,7 +6508,14 @@
         <p:cNvGrpSpPr/>
         <p:nvPr/>
       </p:nvGrpSpPr>
-      <p:grpSpPr/>
+      <p:grpSpPr>
+        <a:xfrm>
+          <a:off x="0" y="0"/>
+          <a:ext cx="0" cy="0"/>
+          <a:chOff x="0" y="0"/>
+          <a:chExt cx="0" cy="0"/>
+        </a:xfrm>
+      </p:grpSpPr>
       <p:sp>
         <p:nvSpPr>
           <p:cNvPr id="2" name="TextBox 1"/>
@@ -5656,6 +6591,7 @@
           <a:lstStyle/>
           <a:p>
             <a:pPr algn="ctr"/>
+            <a:endParaRPr/>
           </a:p>
         </p:txBody>
       </p:sp>
@@ -5831,7 +6767,7 @@
 </file>
 
 <file path=ppt/slides/slide2.xml><?xml version="1.0" encoding="utf-8"?>
-<p:sld xmlns:a="http://schemas.openxmlformats.org/drawingml/2006/main" xmlns:p="http://schemas.openxmlformats.org/presentationml/2006/main" xmlns:r="http://schemas.openxmlformats.org/officeDocument/2006/relationships">
+<p:sld xmlns:a="http://schemas.openxmlformats.org/drawingml/2006/main" xmlns:r="http://schemas.openxmlformats.org/officeDocument/2006/relationships" xmlns:p="http://schemas.openxmlformats.org/presentationml/2006/main">
   <p:cSld>
     <p:bg>
       <p:bgPr>
@@ -5847,7 +6783,14 @@
         <p:cNvGrpSpPr/>
         <p:nvPr/>
       </p:nvGrpSpPr>
-      <p:grpSpPr/>
+      <p:grpSpPr>
+        <a:xfrm>
+          <a:off x="0" y="0"/>
+          <a:ext cx="0" cy="0"/>
+          <a:chOff x="0" y="0"/>
+          <a:chExt cx="0" cy="0"/>
+        </a:xfrm>
+      </p:grpSpPr>
       <p:sp>
         <p:nvSpPr>
           <p:cNvPr id="2" name="TextBox 1"/>
@@ -5923,6 +6866,7 @@
           <a:lstStyle/>
           <a:p>
             <a:pPr algn="ctr"/>
+            <a:endParaRPr/>
           </a:p>
         </p:txBody>
       </p:sp>
@@ -6023,7 +6967,7 @@
 </file>
 
 <file path=ppt/slides/slide20.xml><?xml version="1.0" encoding="utf-8"?>
-<p:sld xmlns:a="http://schemas.openxmlformats.org/drawingml/2006/main" xmlns:p="http://schemas.openxmlformats.org/presentationml/2006/main" xmlns:r="http://schemas.openxmlformats.org/officeDocument/2006/relationships">
+<p:sld xmlns:a="http://schemas.openxmlformats.org/drawingml/2006/main" xmlns:r="http://schemas.openxmlformats.org/officeDocument/2006/relationships" xmlns:p="http://schemas.openxmlformats.org/presentationml/2006/main">
   <p:cSld>
     <p:bg>
       <p:bgPr>
@@ -6039,7 +6983,14 @@
         <p:cNvGrpSpPr/>
         <p:nvPr/>
       </p:nvGrpSpPr>
-      <p:grpSpPr/>
+      <p:grpSpPr>
+        <a:xfrm>
+          <a:off x="0" y="0"/>
+          <a:ext cx="0" cy="0"/>
+          <a:chOff x="0" y="0"/>
+          <a:chExt cx="0" cy="0"/>
+        </a:xfrm>
+      </p:grpSpPr>
       <p:sp>
         <p:nvSpPr>
           <p:cNvPr id="2" name="TextBox 1"/>
@@ -6115,6 +7066,7 @@
           <a:lstStyle/>
           <a:p>
             <a:pPr algn="ctr"/>
+            <a:endParaRPr/>
           </a:p>
         </p:txBody>
       </p:sp>
@@ -6250,7 +7202,7 @@
 </file>
 
 <file path=ppt/slides/slide21.xml><?xml version="1.0" encoding="utf-8"?>
-<p:sld xmlns:a="http://schemas.openxmlformats.org/drawingml/2006/main" xmlns:p="http://schemas.openxmlformats.org/presentationml/2006/main" xmlns:r="http://schemas.openxmlformats.org/officeDocument/2006/relationships">
+<p:sld xmlns:a="http://schemas.openxmlformats.org/drawingml/2006/main" xmlns:r="http://schemas.openxmlformats.org/officeDocument/2006/relationships" xmlns:p="http://schemas.openxmlformats.org/presentationml/2006/main">
   <p:cSld>
     <p:bg>
       <p:bgPr>
@@ -6266,7 +7218,14 @@
         <p:cNvGrpSpPr/>
         <p:nvPr/>
       </p:nvGrpSpPr>
-      <p:grpSpPr/>
+      <p:grpSpPr>
+        <a:xfrm>
+          <a:off x="0" y="0"/>
+          <a:ext cx="0" cy="0"/>
+          <a:chOff x="0" y="0"/>
+          <a:chExt cx="0" cy="0"/>
+        </a:xfrm>
+      </p:grpSpPr>
       <p:sp>
         <p:nvSpPr>
           <p:cNvPr id="2" name="TextBox 1"/>
@@ -6342,6 +7301,7 @@
           <a:lstStyle/>
           <a:p>
             <a:pPr algn="ctr"/>
+            <a:endParaRPr/>
           </a:p>
         </p:txBody>
       </p:sp>
@@ -6474,6 +7434,7 @@
           <a:lstStyle/>
           <a:p>
             <a:pPr algn="ctr"/>
+            <a:endParaRPr/>
           </a:p>
         </p:txBody>
       </p:sp>
@@ -6571,6 +7532,7 @@
           <a:lstStyle/>
           <a:p>
             <a:pPr algn="ctr"/>
+            <a:endParaRPr/>
           </a:p>
         </p:txBody>
       </p:sp>
@@ -6668,6 +7630,7 @@
           <a:lstStyle/>
           <a:p>
             <a:pPr algn="ctr"/>
+            <a:endParaRPr/>
           </a:p>
         </p:txBody>
       </p:sp>
@@ -6765,6 +7728,7 @@
           <a:lstStyle/>
           <a:p>
             <a:pPr algn="ctr"/>
+            <a:endParaRPr/>
           </a:p>
         </p:txBody>
       </p:sp>
@@ -6889,7 +7853,7 @@
 </file>
 
 <file path=ppt/slides/slide3.xml><?xml version="1.0" encoding="utf-8"?>
-<p:sld xmlns:a="http://schemas.openxmlformats.org/drawingml/2006/main" xmlns:p="http://schemas.openxmlformats.org/presentationml/2006/main" xmlns:r="http://schemas.openxmlformats.org/officeDocument/2006/relationships">
+<p:sld xmlns:a="http://schemas.openxmlformats.org/drawingml/2006/main" xmlns:r="http://schemas.openxmlformats.org/officeDocument/2006/relationships" xmlns:p="http://schemas.openxmlformats.org/presentationml/2006/main">
   <p:cSld>
     <p:bg>
       <p:bgPr>
@@ -6905,7 +7869,14 @@
         <p:cNvGrpSpPr/>
         <p:nvPr/>
       </p:nvGrpSpPr>
-      <p:grpSpPr/>
+      <p:grpSpPr>
+        <a:xfrm>
+          <a:off x="0" y="0"/>
+          <a:ext cx="0" cy="0"/>
+          <a:chOff x="0" y="0"/>
+          <a:chExt cx="0" cy="0"/>
+        </a:xfrm>
+      </p:grpSpPr>
       <p:sp>
         <p:nvSpPr>
           <p:cNvPr id="2" name="TextBox 1"/>
@@ -6981,6 +7952,7 @@
           <a:lstStyle/>
           <a:p>
             <a:pPr algn="ctr"/>
+            <a:endParaRPr/>
           </a:p>
         </p:txBody>
       </p:sp>
@@ -7156,7 +8128,7 @@
 </file>
 
 <file path=ppt/slides/slide4.xml><?xml version="1.0" encoding="utf-8"?>
-<p:sld xmlns:a="http://schemas.openxmlformats.org/drawingml/2006/main" xmlns:p="http://schemas.openxmlformats.org/presentationml/2006/main" xmlns:r="http://schemas.openxmlformats.org/officeDocument/2006/relationships">
+<p:sld xmlns:a="http://schemas.openxmlformats.org/drawingml/2006/main" xmlns:r="http://schemas.openxmlformats.org/officeDocument/2006/relationships" xmlns:p="http://schemas.openxmlformats.org/presentationml/2006/main">
   <p:cSld>
     <p:bg>
       <p:bgPr>
@@ -7172,7 +8144,14 @@
         <p:cNvGrpSpPr/>
         <p:nvPr/>
       </p:nvGrpSpPr>
-      <p:grpSpPr/>
+      <p:grpSpPr>
+        <a:xfrm>
+          <a:off x="0" y="0"/>
+          <a:ext cx="0" cy="0"/>
+          <a:chOff x="0" y="0"/>
+          <a:chExt cx="0" cy="0"/>
+        </a:xfrm>
+      </p:grpSpPr>
       <p:sp>
         <p:nvSpPr>
           <p:cNvPr id="2" name="TextBox 1"/>
@@ -7283,6 +8262,7 @@
           <a:lstStyle/>
           <a:p>
             <a:pPr algn="ctr"/>
+            <a:endParaRPr/>
           </a:p>
         </p:txBody>
       </p:sp>
@@ -7415,6 +8395,7 @@
           <a:lstStyle/>
           <a:p>
             <a:pPr algn="ctr"/>
+            <a:endParaRPr/>
           </a:p>
         </p:txBody>
       </p:sp>
@@ -7516,6 +8497,7 @@
           <a:lstStyle/>
           <a:p>
             <a:pPr algn="ctr"/>
+            <a:endParaRPr/>
           </a:p>
         </p:txBody>
       </p:sp>
@@ -7613,6 +8595,7 @@
           <a:lstStyle/>
           <a:p>
             <a:pPr algn="ctr"/>
+            <a:endParaRPr/>
           </a:p>
         </p:txBody>
       </p:sp>
@@ -7710,6 +8693,7 @@
           <a:lstStyle/>
           <a:p>
             <a:pPr algn="ctr"/>
+            <a:endParaRPr/>
           </a:p>
         </p:txBody>
       </p:sp>
@@ -7844,7 +8828,7 @@
 </file>
 
 <file path=ppt/slides/slide5.xml><?xml version="1.0" encoding="utf-8"?>
-<p:sld xmlns:a="http://schemas.openxmlformats.org/drawingml/2006/main" xmlns:p="http://schemas.openxmlformats.org/presentationml/2006/main" xmlns:r="http://schemas.openxmlformats.org/officeDocument/2006/relationships">
+<p:sld xmlns:a="http://schemas.openxmlformats.org/drawingml/2006/main" xmlns:r="http://schemas.openxmlformats.org/officeDocument/2006/relationships" xmlns:p="http://schemas.openxmlformats.org/presentationml/2006/main">
   <p:cSld>
     <p:bg>
       <p:bgPr>
@@ -7860,7 +8844,14 @@
         <p:cNvGrpSpPr/>
         <p:nvPr/>
       </p:nvGrpSpPr>
-      <p:grpSpPr/>
+      <p:grpSpPr>
+        <a:xfrm>
+          <a:off x="0" y="0"/>
+          <a:ext cx="0" cy="0"/>
+          <a:chOff x="0" y="0"/>
+          <a:chExt cx="0" cy="0"/>
+        </a:xfrm>
+      </p:grpSpPr>
       <p:sp>
         <p:nvSpPr>
           <p:cNvPr id="2" name="TextBox 1"/>
@@ -7936,6 +8927,7 @@
           <a:lstStyle/>
           <a:p>
             <a:pPr algn="ctr"/>
+            <a:endParaRPr/>
           </a:p>
         </p:txBody>
       </p:sp>
@@ -8068,6 +9060,7 @@
           <a:lstStyle/>
           <a:p>
             <a:pPr algn="ctr"/>
+            <a:endParaRPr/>
           </a:p>
         </p:txBody>
       </p:sp>
@@ -8165,6 +9158,7 @@
           <a:lstStyle/>
           <a:p>
             <a:pPr algn="ctr"/>
+            <a:endParaRPr/>
           </a:p>
         </p:txBody>
       </p:sp>
@@ -8262,6 +9256,7 @@
           <a:lstStyle/>
           <a:p>
             <a:pPr algn="ctr"/>
+            <a:endParaRPr/>
           </a:p>
         </p:txBody>
       </p:sp>
@@ -8359,6 +9354,7 @@
           <a:lstStyle/>
           <a:p>
             <a:pPr algn="ctr"/>
+            <a:endParaRPr/>
           </a:p>
         </p:txBody>
       </p:sp>
@@ -8497,7 +9493,7 @@
 </file>
 
 <file path=ppt/slides/slide6.xml><?xml version="1.0" encoding="utf-8"?>
-<p:sld xmlns:a="http://schemas.openxmlformats.org/drawingml/2006/main" xmlns:p="http://schemas.openxmlformats.org/presentationml/2006/main" xmlns:r="http://schemas.openxmlformats.org/officeDocument/2006/relationships">
+<p:sld xmlns:a="http://schemas.openxmlformats.org/drawingml/2006/main" xmlns:r="http://schemas.openxmlformats.org/officeDocument/2006/relationships" xmlns:p="http://schemas.openxmlformats.org/presentationml/2006/main">
   <p:cSld>
     <p:bg>
       <p:bgPr>
@@ -8513,7 +9509,14 @@
         <p:cNvGrpSpPr/>
         <p:nvPr/>
       </p:nvGrpSpPr>
-      <p:grpSpPr/>
+      <p:grpSpPr>
+        <a:xfrm>
+          <a:off x="0" y="0"/>
+          <a:ext cx="0" cy="0"/>
+          <a:chOff x="0" y="0"/>
+          <a:chExt cx="0" cy="0"/>
+        </a:xfrm>
+      </p:grpSpPr>
       <p:sp>
         <p:nvSpPr>
           <p:cNvPr id="2" name="TextBox 1"/>
@@ -8589,6 +9592,7 @@
           <a:lstStyle/>
           <a:p>
             <a:pPr algn="ctr"/>
+            <a:endParaRPr/>
           </a:p>
         </p:txBody>
       </p:sp>
@@ -8665,7 +9669,7 @@
           </a:fontRef>
         </p:style>
         <p:txBody>
-          <a:bodyPr rtlCol="0" anchor="ctr" wrap="square"/>
+          <a:bodyPr wrap="square" rtlCol="0" anchor="ctr"/>
           <a:lstStyle/>
           <a:p>
             <a:pPr algn="ctr">
@@ -8762,7 +9766,7 @@
 </file>
 
 <file path=ppt/slides/slide7.xml><?xml version="1.0" encoding="utf-8"?>
-<p:sld xmlns:a="http://schemas.openxmlformats.org/drawingml/2006/main" xmlns:p="http://schemas.openxmlformats.org/presentationml/2006/main" xmlns:r="http://schemas.openxmlformats.org/officeDocument/2006/relationships">
+<p:sld xmlns:a="http://schemas.openxmlformats.org/drawingml/2006/main" xmlns:r="http://schemas.openxmlformats.org/officeDocument/2006/relationships" xmlns:p="http://schemas.openxmlformats.org/presentationml/2006/main">
   <p:cSld>
     <p:bg>
       <p:bgPr>
@@ -8778,7 +9782,14 @@
         <p:cNvGrpSpPr/>
         <p:nvPr/>
       </p:nvGrpSpPr>
-      <p:grpSpPr/>
+      <p:grpSpPr>
+        <a:xfrm>
+          <a:off x="0" y="0"/>
+          <a:ext cx="0" cy="0"/>
+          <a:chOff x="0" y="0"/>
+          <a:chExt cx="0" cy="0"/>
+        </a:xfrm>
+      </p:grpSpPr>
       <p:sp>
         <p:nvSpPr>
           <p:cNvPr id="2" name="TextBox 1"/>
@@ -8854,6 +9865,7 @@
           <a:lstStyle/>
           <a:p>
             <a:pPr algn="ctr"/>
+            <a:endParaRPr/>
           </a:p>
         </p:txBody>
       </p:sp>
@@ -8930,7 +9942,7 @@
           </a:fontRef>
         </p:style>
         <p:txBody>
-          <a:bodyPr rtlCol="0" anchor="ctr" wrap="square"/>
+          <a:bodyPr wrap="square" rtlCol="0" anchor="ctr"/>
           <a:lstStyle/>
           <a:p>
             <a:r>
@@ -8942,7 +9954,9 @@
               <a:t>cd C:\Users\biome\Documents\PrimeServicesGroupKC\car-rental-microservices</a:t>
             </a:r>
           </a:p>
-          <a:p/>
+          <a:p>
+            <a:endParaRPr/>
+          </a:p>
           <a:p>
             <a:r>
               <a:t># Confirm this is the Git repository root</a:t>
@@ -8958,7 +9972,9 @@
               <a:t>git status</a:t>
             </a:r>
           </a:p>
-          <a:p/>
+          <a:p>
+            <a:endParaRPr/>
+          </a:p>
           <a:p>
             <a:r>
               <a:t># Open the repository in VS Code</a:t>
@@ -8969,7 +9985,9 @@
               <a:t>code .</a:t>
             </a:r>
           </a:p>
-          <a:p/>
+          <a:p>
+            <a:endParaRPr/>
+          </a:p>
           <a:p>
             <a:r>
               <a:t># Enter the learning path for Project 1</a:t>
@@ -9019,7 +10037,7 @@
 </file>
 
 <file path=ppt/slides/slide8.xml><?xml version="1.0" encoding="utf-8"?>
-<p:sld xmlns:a="http://schemas.openxmlformats.org/drawingml/2006/main" xmlns:p="http://schemas.openxmlformats.org/presentationml/2006/main" xmlns:r="http://schemas.openxmlformats.org/officeDocument/2006/relationships">
+<p:sld xmlns:a="http://schemas.openxmlformats.org/drawingml/2006/main" xmlns:r="http://schemas.openxmlformats.org/officeDocument/2006/relationships" xmlns:p="http://schemas.openxmlformats.org/presentationml/2006/main">
   <p:cSld>
     <p:bg>
       <p:bgPr>
@@ -9035,7 +10053,14 @@
         <p:cNvGrpSpPr/>
         <p:nvPr/>
       </p:nvGrpSpPr>
-      <p:grpSpPr/>
+      <p:grpSpPr>
+        <a:xfrm>
+          <a:off x="0" y="0"/>
+          <a:ext cx="0" cy="0"/>
+          <a:chOff x="0" y="0"/>
+          <a:chExt cx="0" cy="0"/>
+        </a:xfrm>
+      </p:grpSpPr>
       <p:sp>
         <p:nvSpPr>
           <p:cNvPr id="2" name="TextBox 1"/>
@@ -9111,6 +10136,7 @@
           <a:lstStyle/>
           <a:p>
             <a:pPr algn="ctr"/>
+            <a:endParaRPr/>
           </a:p>
         </p:txBody>
       </p:sp>
@@ -9187,7 +10213,7 @@
           </a:fontRef>
         </p:style>
         <p:txBody>
-          <a:bodyPr rtlCol="0" anchor="ctr" wrap="square"/>
+          <a:bodyPr wrap="square" rtlCol="0" anchor="ctr"/>
           <a:lstStyle/>
           <a:p>
             <a:r>
@@ -9290,7 +10316,7 @@
 </file>
 
 <file path=ppt/slides/slide9.xml><?xml version="1.0" encoding="utf-8"?>
-<p:sld xmlns:a="http://schemas.openxmlformats.org/drawingml/2006/main" xmlns:p="http://schemas.openxmlformats.org/presentationml/2006/main" xmlns:r="http://schemas.openxmlformats.org/officeDocument/2006/relationships">
+<p:sld xmlns:a="http://schemas.openxmlformats.org/drawingml/2006/main" xmlns:r="http://schemas.openxmlformats.org/officeDocument/2006/relationships" xmlns:p="http://schemas.openxmlformats.org/presentationml/2006/main">
   <p:cSld>
     <p:bg>
       <p:bgPr>
@@ -9306,7 +10332,14 @@
         <p:cNvGrpSpPr/>
         <p:nvPr/>
       </p:nvGrpSpPr>
-      <p:grpSpPr/>
+      <p:grpSpPr>
+        <a:xfrm>
+          <a:off x="0" y="0"/>
+          <a:ext cx="0" cy="0"/>
+          <a:chOff x="0" y="0"/>
+          <a:chExt cx="0" cy="0"/>
+        </a:xfrm>
+      </p:grpSpPr>
       <p:sp>
         <p:nvSpPr>
           <p:cNvPr id="2" name="TextBox 1"/>
@@ -9382,6 +10415,7 @@
           <a:lstStyle/>
           <a:p>
             <a:pPr algn="ctr"/>
+            <a:endParaRPr/>
           </a:p>
         </p:txBody>
       </p:sp>

</xml_diff>